<commit_message>
Redesign slide 1, add /deck page with slide viewer and download
- Simplified slide 1: bold headline, 3 clean stats, focused thesis section
- Added DeckPage with slide toggle, navigation arrows, and .pptx download
- Added react-router-dom for /deck route
- Hero CTA now links to /deck page instead of raw .pptx file
- Added vercel.json for SPA routing support

Co-Authored-By: Claude Opus 4.6 <noreply@anthropic.com>
</commit_message>
<xml_diff>
--- a/public/deck/iShares_Direct_Personalization_2_Slides.pptx
+++ b/public/deck/iShares_Direct_Personalization_2_Slides.pptx
@@ -1010,7 +1010,7 @@
                 <a:ea typeface="Arial Black" pitchFamily="34" charset="-122"/>
                 <a:cs typeface="Arial Black" pitchFamily="34" charset="-120"/>
               </a:rPr>
-              <a:t>From ETF Provider to Personalization Engine</a:t>
+              <a:t>iShares Can Own the Personalization Layer</a:t>
             </a:r>
             <a:endParaRPr lang="en-US" sz="2700" dirty="0"/>
           </a:p>
@@ -1024,7 +1024,7 @@
         </p:nvSpPr>
         <p:spPr>
           <a:xfrm>
-            <a:off x="457200" y="868680"/>
+            <a:off x="457200" y="777240"/>
             <a:ext cx="8229600" cy="548640"/>
           </a:xfrm>
           <a:prstGeom prst="rect">
@@ -1049,7 +1049,7 @@
                 <a:ea typeface="Arial" pitchFamily="34" charset="-122"/>
                 <a:cs typeface="Arial" pitchFamily="34" charset="-120"/>
               </a:rPr>
-              <a:t>Self-directed investors want personalized portfolio guidance — not just product access. iShares has the lineup to deliver it.</a:t>
+              <a:t>75M+ self-directed investors want portfolio guidance — not just product access. iShares has the scale, lineup, and brand to deliver it.</a:t>
             </a:r>
             <a:endParaRPr lang="en-US" sz="1350" dirty="0"/>
           </a:p>
@@ -1057,14 +1057,37 @@
       </p:sp>
       <p:sp>
         <p:nvSpPr>
-          <p:cNvPr id="5" name="Text 3"/>
-          <p:cNvSpPr/>
-          <p:nvPr/>
-        </p:nvSpPr>
-        <p:spPr>
-          <a:xfrm>
-            <a:off x="274320" y="1508760"/>
-            <a:ext cx="2011680" cy="640080"/>
+          <p:cNvPr id="5" name="Shape 3"/>
+          <p:cNvSpPr/>
+          <p:nvPr/>
+        </p:nvSpPr>
+        <p:spPr>
+          <a:xfrm>
+            <a:off x="457200" y="2468880"/>
+            <a:ext cx="8229600" cy="0"/>
+          </a:xfrm>
+          <a:prstGeom prst="line">
+            <a:avLst/>
+          </a:prstGeom>
+          <a:noFill/>
+          <a:ln w="12700">
+            <a:solidFill>
+              <a:srgbClr val="E5E5E5"/>
+            </a:solidFill>
+            <a:prstDash val="solid"/>
+          </a:ln>
+        </p:spPr>
+      </p:sp>
+      <p:sp>
+        <p:nvSpPr>
+          <p:cNvPr id="6" name="Text 4"/>
+          <p:cNvSpPr/>
+          <p:nvPr/>
+        </p:nvSpPr>
+        <p:spPr>
+          <a:xfrm>
+            <a:off x="457200" y="1417320"/>
+            <a:ext cx="2743200" cy="594360"/>
           </a:xfrm>
           <a:prstGeom prst="rect">
             <a:avLst/>
@@ -1080,7 +1103,7 @@
               <a:buNone/>
             </a:pPr>
             <a:r>
-              <a:rPr lang="en-US" sz="4400" b="1" dirty="0">
+              <a:rPr lang="en-US" sz="4000" b="1" dirty="0">
                 <a:solidFill>
                   <a:srgbClr val="F6693D"/>
                 </a:solidFill>
@@ -1090,20 +1113,20 @@
               </a:rPr>
               <a:t>$3.9T+</a:t>
             </a:r>
-            <a:endParaRPr lang="en-US" sz="4400" dirty="0"/>
-          </a:p>
-        </p:txBody>
-      </p:sp>
-      <p:sp>
-        <p:nvSpPr>
-          <p:cNvPr id="6" name="Text 4"/>
-          <p:cNvSpPr/>
-          <p:nvPr/>
-        </p:nvSpPr>
-        <p:spPr>
-          <a:xfrm>
-            <a:off x="274320" y="2103120"/>
-            <a:ext cx="2011680" cy="411480"/>
+            <a:endParaRPr lang="en-US" sz="4000" dirty="0"/>
+          </a:p>
+        </p:txBody>
+      </p:sp>
+      <p:sp>
+        <p:nvSpPr>
+          <p:cNvPr id="7" name="Text 5"/>
+          <p:cNvSpPr/>
+          <p:nvPr/>
+        </p:nvSpPr>
+        <p:spPr>
+          <a:xfrm>
+            <a:off x="457200" y="1965960"/>
+            <a:ext cx="2743200" cy="365760"/>
           </a:xfrm>
           <a:prstGeom prst="rect">
             <a:avLst/>
@@ -1135,14 +1158,14 @@
       </p:sp>
       <p:sp>
         <p:nvSpPr>
-          <p:cNvPr id="7" name="Text 5"/>
-          <p:cNvSpPr/>
-          <p:nvPr/>
-        </p:nvSpPr>
-        <p:spPr>
-          <a:xfrm>
-            <a:off x="2468880" y="1508760"/>
-            <a:ext cx="2011680" cy="640080"/>
+          <p:cNvPr id="8" name="Text 6"/>
+          <p:cNvSpPr/>
+          <p:nvPr/>
+        </p:nvSpPr>
+        <p:spPr>
+          <a:xfrm>
+            <a:off x="3200400" y="1417320"/>
+            <a:ext cx="2743200" cy="594360"/>
           </a:xfrm>
           <a:prstGeom prst="rect">
             <a:avLst/>
@@ -1158,7 +1181,7 @@
               <a:buNone/>
             </a:pPr>
             <a:r>
-              <a:rPr lang="en-US" sz="4400" b="1" dirty="0">
+              <a:rPr lang="en-US" sz="4000" b="1" dirty="0">
                 <a:solidFill>
                   <a:srgbClr val="F6693D"/>
                 </a:solidFill>
@@ -1166,22 +1189,22 @@
                 <a:ea typeface="Arial Black" pitchFamily="34" charset="-122"/>
                 <a:cs typeface="Arial Black" pitchFamily="34" charset="-120"/>
               </a:rPr>
-              <a:t>400+</a:t>
-            </a:r>
-            <a:endParaRPr lang="en-US" sz="4400" dirty="0"/>
-          </a:p>
-        </p:txBody>
-      </p:sp>
-      <p:sp>
-        <p:nvSpPr>
-          <p:cNvPr id="8" name="Text 6"/>
-          <p:cNvSpPr/>
-          <p:nvPr/>
-        </p:nvSpPr>
-        <p:spPr>
-          <a:xfrm>
-            <a:off x="2468880" y="2103120"/>
-            <a:ext cx="2011680" cy="411480"/>
+              <a:t>430+</a:t>
+            </a:r>
+            <a:endParaRPr lang="en-US" sz="4000" dirty="0"/>
+          </a:p>
+        </p:txBody>
+      </p:sp>
+      <p:sp>
+        <p:nvSpPr>
+          <p:cNvPr id="9" name="Text 7"/>
+          <p:cNvSpPr/>
+          <p:nvPr/>
+        </p:nvSpPr>
+        <p:spPr>
+          <a:xfrm>
+            <a:off x="3200400" y="1965960"/>
+            <a:ext cx="2743200" cy="365760"/>
           </a:xfrm>
           <a:prstGeom prst="rect">
             <a:avLst/>
@@ -1213,14 +1236,14 @@
       </p:sp>
       <p:sp>
         <p:nvSpPr>
-          <p:cNvPr id="9" name="Text 7"/>
-          <p:cNvSpPr/>
-          <p:nvPr/>
-        </p:nvSpPr>
-        <p:spPr>
-          <a:xfrm>
-            <a:off x="4663440" y="1508760"/>
-            <a:ext cx="2011680" cy="640080"/>
+          <p:cNvPr id="10" name="Text 8"/>
+          <p:cNvSpPr/>
+          <p:nvPr/>
+        </p:nvSpPr>
+        <p:spPr>
+          <a:xfrm>
+            <a:off x="5943600" y="1417320"/>
+            <a:ext cx="2743200" cy="594360"/>
           </a:xfrm>
           <a:prstGeom prst="rect">
             <a:avLst/>
@@ -1236,7 +1259,7 @@
               <a:buNone/>
             </a:pPr>
             <a:r>
-              <a:rPr lang="en-US" sz="4400" b="1" dirty="0">
+              <a:rPr lang="en-US" sz="4000" b="1" dirty="0">
                 <a:solidFill>
                   <a:srgbClr val="F6693D"/>
                 </a:solidFill>
@@ -1244,22 +1267,22 @@
                 <a:ea typeface="Arial Black" pitchFamily="34" charset="-122"/>
                 <a:cs typeface="Arial Black" pitchFamily="34" charset="-120"/>
               </a:rPr>
-              <a:t>80M+</a:t>
-            </a:r>
-            <a:endParaRPr lang="en-US" sz="4400" dirty="0"/>
-          </a:p>
-        </p:txBody>
-      </p:sp>
-      <p:sp>
-        <p:nvSpPr>
-          <p:cNvPr id="10" name="Text 8"/>
-          <p:cNvSpPr/>
-          <p:nvPr/>
-        </p:nvSpPr>
-        <p:spPr>
-          <a:xfrm>
-            <a:off x="4663440" y="2103120"/>
-            <a:ext cx="2011680" cy="411480"/>
+              <a:t>75M+</a:t>
+            </a:r>
+            <a:endParaRPr lang="en-US" sz="4000" dirty="0"/>
+          </a:p>
+        </p:txBody>
+      </p:sp>
+      <p:sp>
+        <p:nvSpPr>
+          <p:cNvPr id="11" name="Text 9"/>
+          <p:cNvSpPr/>
+          <p:nvPr/>
+        </p:nvSpPr>
+        <p:spPr>
+          <a:xfrm>
+            <a:off x="5943600" y="1965960"/>
+            <a:ext cx="2743200" cy="365760"/>
           </a:xfrm>
           <a:prstGeom prst="rect">
             <a:avLst/>
@@ -1283,39 +1306,22 @@
                 <a:ea typeface="Arial" pitchFamily="34" charset="-122"/>
                 <a:cs typeface="Arial" pitchFamily="34" charset="-120"/>
               </a:rPr>
-              <a:t>Self-Directed</a:t>
+              <a:t>Self-Directed Accounts</a:t>
             </a:r>
             <a:endParaRPr lang="en-US" sz="1100" dirty="0"/>
           </a:p>
-          <a:p>
-            <a:pPr algn="ctr" indent="0" marL="0">
-              <a:buNone/>
-            </a:pPr>
-            <a:r>
-              <a:rPr lang="en-US" sz="1100" dirty="0">
-                <a:solidFill>
-                  <a:srgbClr val="666666"/>
-                </a:solidFill>
-                <a:latin typeface="Arial" pitchFamily="34" charset="0"/>
-                <a:ea typeface="Arial" pitchFamily="34" charset="-122"/>
-                <a:cs typeface="Arial" pitchFamily="34" charset="-120"/>
-              </a:rPr>
-              <a:t>Investor Accounts</a:t>
-            </a:r>
-            <a:endParaRPr lang="en-US" sz="1100" dirty="0"/>
-          </a:p>
-        </p:txBody>
-      </p:sp>
-      <p:sp>
-        <p:nvSpPr>
-          <p:cNvPr id="11" name="Text 9"/>
-          <p:cNvSpPr/>
-          <p:nvPr/>
-        </p:nvSpPr>
-        <p:spPr>
-          <a:xfrm>
-            <a:off x="6858000" y="1508760"/>
-            <a:ext cx="2011680" cy="640080"/>
+        </p:txBody>
+      </p:sp>
+      <p:sp>
+        <p:nvSpPr>
+          <p:cNvPr id="12" name="Text 10"/>
+          <p:cNvSpPr/>
+          <p:nvPr/>
+        </p:nvSpPr>
+        <p:spPr>
+          <a:xfrm>
+            <a:off x="457200" y="2606040"/>
+            <a:ext cx="8229600" cy="274320"/>
           </a:xfrm>
           <a:prstGeom prst="rect">
             <a:avLst/>
@@ -1327,95 +1333,288 @@
           <a:bodyPr wrap="square" lIns="0" tIns="0" rIns="0" bIns="0" rtlCol="0" anchor="ctr"/>
           <a:lstStyle/>
           <a:p>
-            <a:pPr algn="ctr" indent="0" marL="0">
-              <a:buNone/>
-            </a:pPr>
-            <a:r>
-              <a:rPr lang="en-US" sz="4400" b="1" dirty="0">
-                <a:solidFill>
-                  <a:srgbClr val="FFB800"/>
-                </a:solidFill>
-                <a:latin typeface="Arial Black" pitchFamily="34" charset="0"/>
-                <a:ea typeface="Arial Black" pitchFamily="34" charset="-122"/>
-                <a:cs typeface="Arial Black" pitchFamily="34" charset="-120"/>
-              </a:rPr>
-              <a:t>#1</a:t>
-            </a:r>
-            <a:endParaRPr lang="en-US" sz="4400" dirty="0"/>
-          </a:p>
-        </p:txBody>
-      </p:sp>
-      <p:sp>
-        <p:nvSpPr>
-          <p:cNvPr id="12" name="Text 10"/>
-          <p:cNvSpPr/>
-          <p:nvPr/>
-        </p:nvSpPr>
-        <p:spPr>
-          <a:xfrm>
-            <a:off x="6858000" y="2103120"/>
-            <a:ext cx="2011680" cy="411480"/>
-          </a:xfrm>
-          <a:prstGeom prst="rect">
-            <a:avLst/>
-          </a:prstGeom>
-          <a:noFill/>
-          <a:ln/>
-        </p:spPr>
-        <p:txBody>
-          <a:bodyPr wrap="square" lIns="0" tIns="0" rIns="0" bIns="0" rtlCol="0" anchor="ctr"/>
-          <a:lstStyle/>
-          <a:p>
-            <a:pPr algn="ctr" indent="0" marL="0">
-              <a:buNone/>
-            </a:pPr>
-            <a:r>
-              <a:rPr lang="en-US" sz="1100" dirty="0">
-                <a:solidFill>
-                  <a:srgbClr val="666666"/>
-                </a:solidFill>
-                <a:latin typeface="Arial" pitchFamily="34" charset="0"/>
-                <a:ea typeface="Arial" pitchFamily="34" charset="-122"/>
-                <a:cs typeface="Arial" pitchFamily="34" charset="-120"/>
-              </a:rPr>
-              <a:t>Global ETF</a:t>
-            </a:r>
-            <a:endParaRPr lang="en-US" sz="1100" dirty="0"/>
-          </a:p>
-          <a:p>
-            <a:pPr algn="ctr" indent="0" marL="0">
-              <a:buNone/>
-            </a:pPr>
-            <a:r>
-              <a:rPr lang="en-US" sz="1100" dirty="0">
-                <a:solidFill>
-                  <a:srgbClr val="666666"/>
-                </a:solidFill>
-                <a:latin typeface="Arial" pitchFamily="34" charset="0"/>
-                <a:ea typeface="Arial" pitchFamily="34" charset="-122"/>
-                <a:cs typeface="Arial" pitchFamily="34" charset="-120"/>
-              </a:rPr>
-              <a:t>Brand</a:t>
-            </a:r>
-            <a:endParaRPr lang="en-US" sz="1100" dirty="0"/>
-          </a:p>
-        </p:txBody>
-      </p:sp>
-      <p:sp>
-        <p:nvSpPr>
-          <p:cNvPr id="13" name="Shape 11"/>
-          <p:cNvSpPr/>
-          <p:nvPr/>
-        </p:nvSpPr>
-        <p:spPr>
-          <a:xfrm>
-            <a:off x="457200" y="2606040"/>
-            <a:ext cx="8229600" cy="1737360"/>
-          </a:xfrm>
-          <a:prstGeom prst="rect">
-            <a:avLst>
-              <a:gd name="adj" fmla="val 5263"/>
-            </a:avLst>
+            <a:pPr indent="0" marL="0">
+              <a:buNone/>
+            </a:pPr>
+            <a:r>
+              <a:rPr lang="en-US" sz="900" b="1" dirty="0">
+                <a:solidFill>
+                  <a:srgbClr val="F6693D"/>
+                </a:solidFill>
+                <a:latin typeface="Arial" pitchFamily="34" charset="0"/>
+                <a:ea typeface="Arial" pitchFamily="34" charset="-122"/>
+                <a:cs typeface="Arial" pitchFamily="34" charset="-120"/>
+              </a:rPr>
+              <a:t>THE OPPORTUNITY</a:t>
+            </a:r>
+            <a:endParaRPr lang="en-US" sz="900" dirty="0"/>
+          </a:p>
+        </p:txBody>
+      </p:sp>
+      <p:sp>
+        <p:nvSpPr>
+          <p:cNvPr id="13" name="Text 11"/>
+          <p:cNvSpPr/>
+          <p:nvPr/>
+        </p:nvSpPr>
+        <p:spPr>
+          <a:xfrm>
+            <a:off x="457200" y="2926080"/>
+            <a:ext cx="8229600" cy="329184"/>
+          </a:xfrm>
+          <a:prstGeom prst="rect">
+            <a:avLst/>
+          </a:prstGeom>
+          <a:noFill/>
+          <a:ln/>
+        </p:spPr>
+        <p:txBody>
+          <a:bodyPr wrap="square" lIns="0" tIns="0" rIns="0" bIns="0" rtlCol="0" anchor="t"/>
+          <a:lstStyle/>
+          <a:p>
+            <a:pPr indent="0" marL="0">
+              <a:buNone/>
+            </a:pPr>
+            <a:r>
+              <a:rPr lang="en-US" sz="1050" b="1" dirty="0">
+                <a:solidFill>
+                  <a:srgbClr val="F6693D"/>
+                </a:solidFill>
+                <a:latin typeface="Arial" pitchFamily="34" charset="0"/>
+                <a:ea typeface="Arial" pitchFamily="34" charset="-122"/>
+                <a:cs typeface="Arial" pitchFamily="34" charset="-120"/>
+              </a:rPr>
+              <a:t>—  </a:t>
+            </a:r>
+            <a:pPr indent="0" marL="0">
+              <a:buNone/>
+            </a:pPr>
+            <a:r>
+              <a:rPr lang="en-US" sz="1050" dirty="0">
+                <a:solidFill>
+                  <a:srgbClr val="333333"/>
+                </a:solidFill>
+                <a:latin typeface="Arial" pitchFamily="34" charset="0"/>
+                <a:ea typeface="Arial" pitchFamily="34" charset="-122"/>
+                <a:cs typeface="Arial" pitchFamily="34" charset="-120"/>
+              </a:rPr>
+              <a:t>Self-directed investors want guidance but won't pay for an advisor — they need a product-embedded solution</a:t>
+            </a:r>
+            <a:endParaRPr lang="en-US" sz="1050" dirty="0"/>
+          </a:p>
+        </p:txBody>
+      </p:sp>
+      <p:sp>
+        <p:nvSpPr>
+          <p:cNvPr id="14" name="Text 12"/>
+          <p:cNvSpPr/>
+          <p:nvPr/>
+        </p:nvSpPr>
+        <p:spPr>
+          <a:xfrm>
+            <a:off x="457200" y="3273552"/>
+            <a:ext cx="8229600" cy="329184"/>
+          </a:xfrm>
+          <a:prstGeom prst="rect">
+            <a:avLst/>
+          </a:prstGeom>
+          <a:noFill/>
+          <a:ln/>
+        </p:spPr>
+        <p:txBody>
+          <a:bodyPr wrap="square" lIns="0" tIns="0" rIns="0" bIns="0" rtlCol="0" anchor="t"/>
+          <a:lstStyle/>
+          <a:p>
+            <a:pPr indent="0" marL="0">
+              <a:buNone/>
+            </a:pPr>
+            <a:r>
+              <a:rPr lang="en-US" sz="1050" b="1" dirty="0">
+                <a:solidFill>
+                  <a:srgbClr val="F6693D"/>
+                </a:solidFill>
+                <a:latin typeface="Arial" pitchFamily="34" charset="0"/>
+                <a:ea typeface="Arial" pitchFamily="34" charset="-122"/>
+                <a:cs typeface="Arial" pitchFamily="34" charset="-120"/>
+              </a:rPr>
+              <a:t>—  </a:t>
+            </a:r>
+            <a:pPr indent="0" marL="0">
+              <a:buNone/>
+            </a:pPr>
+            <a:r>
+              <a:rPr lang="en-US" sz="1050" dirty="0">
+                <a:solidFill>
+                  <a:srgbClr val="333333"/>
+                </a:solidFill>
+                <a:latin typeface="Arial" pitchFamily="34" charset="0"/>
+                <a:ea typeface="Arial" pitchFamily="34" charset="-122"/>
+                <a:cs typeface="Arial" pitchFamily="34" charset="-120"/>
+              </a:rPr>
+              <a:t>Competitors (Schwab, Vanguard, Wealthfront) are racing to own this layer with robo-advisory tools</a:t>
+            </a:r>
+            <a:endParaRPr lang="en-US" sz="1050" dirty="0"/>
+          </a:p>
+        </p:txBody>
+      </p:sp>
+      <p:sp>
+        <p:nvSpPr>
+          <p:cNvPr id="15" name="Text 13"/>
+          <p:cNvSpPr/>
+          <p:nvPr/>
+        </p:nvSpPr>
+        <p:spPr>
+          <a:xfrm>
+            <a:off x="457200" y="3621024"/>
+            <a:ext cx="8229600" cy="329184"/>
+          </a:xfrm>
+          <a:prstGeom prst="rect">
+            <a:avLst/>
+          </a:prstGeom>
+          <a:noFill/>
+          <a:ln/>
+        </p:spPr>
+        <p:txBody>
+          <a:bodyPr wrap="square" lIns="0" tIns="0" rIns="0" bIns="0" rtlCol="0" anchor="t"/>
+          <a:lstStyle/>
+          <a:p>
+            <a:pPr indent="0" marL="0">
+              <a:buNone/>
+            </a:pPr>
+            <a:r>
+              <a:rPr lang="en-US" sz="1050" b="1" dirty="0">
+                <a:solidFill>
+                  <a:srgbClr val="00A854"/>
+                </a:solidFill>
+                <a:latin typeface="Arial" pitchFamily="34" charset="0"/>
+                <a:ea typeface="Arial" pitchFamily="34" charset="-122"/>
+                <a:cs typeface="Arial" pitchFamily="34" charset="-120"/>
+              </a:rPr>
+              <a:t>+  </a:t>
+            </a:r>
+            <a:pPr indent="0" marL="0">
+              <a:buNone/>
+            </a:pPr>
+            <a:r>
+              <a:rPr lang="en-US" sz="1050" dirty="0">
+                <a:solidFill>
+                  <a:srgbClr val="333333"/>
+                </a:solidFill>
+                <a:latin typeface="Arial" pitchFamily="34" charset="0"/>
+                <a:ea typeface="Arial" pitchFamily="34" charset="-122"/>
+                <a:cs typeface="Arial" pitchFamily="34" charset="-120"/>
+              </a:rPr>
+              <a:t>iShares has the broadest ETF lineup, BII capital market assumptions, and institutional credibility to win</a:t>
+            </a:r>
+            <a:endParaRPr lang="en-US" sz="1050" dirty="0"/>
+          </a:p>
+        </p:txBody>
+      </p:sp>
+      <p:sp>
+        <p:nvSpPr>
+          <p:cNvPr id="16" name="Text 14"/>
+          <p:cNvSpPr/>
+          <p:nvPr/>
+        </p:nvSpPr>
+        <p:spPr>
+          <a:xfrm>
+            <a:off x="457200" y="3968496"/>
+            <a:ext cx="8229600" cy="329184"/>
+          </a:xfrm>
+          <a:prstGeom prst="rect">
+            <a:avLst/>
+          </a:prstGeom>
+          <a:noFill/>
+          <a:ln/>
+        </p:spPr>
+        <p:txBody>
+          <a:bodyPr wrap="square" lIns="0" tIns="0" rIns="0" bIns="0" rtlCol="0" anchor="t"/>
+          <a:lstStyle/>
+          <a:p>
+            <a:pPr indent="0" marL="0">
+              <a:buNone/>
+            </a:pPr>
+            <a:r>
+              <a:rPr lang="en-US" sz="1050" b="1" dirty="0">
+                <a:solidFill>
+                  <a:srgbClr val="00A854"/>
+                </a:solidFill>
+                <a:latin typeface="Arial" pitchFamily="34" charset="0"/>
+                <a:ea typeface="Arial" pitchFamily="34" charset="-122"/>
+                <a:cs typeface="Arial" pitchFamily="34" charset="-120"/>
+              </a:rPr>
+              <a:t>+  </a:t>
+            </a:r>
+            <a:pPr indent="0" marL="0">
+              <a:buNone/>
+            </a:pPr>
+            <a:r>
+              <a:rPr lang="en-US" sz="1050" dirty="0">
+                <a:solidFill>
+                  <a:srgbClr val="333333"/>
+                </a:solidFill>
+                <a:latin typeface="Arial" pitchFamily="34" charset="0"/>
+                <a:ea typeface="Arial" pitchFamily="34" charset="-122"/>
+                <a:cs typeface="Arial" pitchFamily="34" charset="-120"/>
+              </a:rPr>
+              <a:t>The path: start with simple allocation models, layer in AI-driven personalization over time</a:t>
+            </a:r>
+            <a:endParaRPr lang="en-US" sz="1050" dirty="0"/>
+          </a:p>
+        </p:txBody>
+      </p:sp>
+      <p:sp>
+        <p:nvSpPr>
+          <p:cNvPr id="17" name="Text 15"/>
+          <p:cNvSpPr/>
+          <p:nvPr/>
+        </p:nvSpPr>
+        <p:spPr>
+          <a:xfrm>
+            <a:off x="457200" y="4160520"/>
+            <a:ext cx="8229600" cy="502920"/>
+          </a:xfrm>
+          <a:prstGeom prst="rect">
+            <a:avLst/>
+          </a:prstGeom>
+          <a:noFill/>
+          <a:ln/>
+        </p:spPr>
+        <p:txBody>
+          <a:bodyPr wrap="square" lIns="0" tIns="0" rIns="0" bIns="0" rtlCol="0" anchor="t"/>
+          <a:lstStyle/>
+          <a:p>
+            <a:pPr indent="0" marL="0">
+              <a:buNone/>
+            </a:pPr>
+            <a:r>
+              <a:rPr lang="en-US" sz="700" dirty="0">
+                <a:solidFill>
+                  <a:srgbClr val="999999"/>
+                </a:solidFill>
+                <a:latin typeface="Arial" pitchFamily="34" charset="0"/>
+                <a:ea typeface="Arial" pitchFamily="34" charset="-122"/>
+                <a:cs typeface="Arial" pitchFamily="34" charset="-120"/>
+              </a:rPr>
+              <a:t>Source: BlackRock (US AUM, ETF count as of Q1 2026). Self-directed accounts: Cerulli Associates.</a:t>
+            </a:r>
+            <a:endParaRPr lang="en-US" sz="700" dirty="0"/>
+          </a:p>
+        </p:txBody>
+      </p:sp>
+      <p:sp>
+        <p:nvSpPr>
+          <p:cNvPr id="18" name="Shape 16"/>
+          <p:cNvSpPr/>
+          <p:nvPr/>
+        </p:nvSpPr>
+        <p:spPr>
+          <a:xfrm>
+            <a:off x="0" y="4526280"/>
+            <a:ext cx="9144000" cy="617220"/>
+          </a:xfrm>
+          <a:prstGeom prst="rect">
+            <a:avLst/>
           </a:prstGeom>
           <a:solidFill>
             <a:srgbClr val="333333"/>
@@ -1425,462 +1624,7 @@
       </p:sp>
       <p:sp>
         <p:nvSpPr>
-          <p:cNvPr id="14" name="Text 12"/>
-          <p:cNvSpPr/>
-          <p:nvPr/>
-        </p:nvSpPr>
-        <p:spPr>
-          <a:xfrm>
-            <a:off x="777240" y="2697480"/>
-            <a:ext cx="3657600" cy="274320"/>
-          </a:xfrm>
-          <a:prstGeom prst="rect">
-            <a:avLst/>
-          </a:prstGeom>
-          <a:noFill/>
-          <a:ln/>
-        </p:spPr>
-        <p:txBody>
-          <a:bodyPr wrap="square" lIns="0" tIns="0" rIns="0" bIns="0" rtlCol="0" anchor="ctr"/>
-          <a:lstStyle/>
-          <a:p>
-            <a:pPr indent="0" marL="0">
-              <a:buNone/>
-            </a:pPr>
-            <a:r>
-              <a:rPr lang="en-US" sz="900" b="1" dirty="0">
-                <a:solidFill>
-                  <a:srgbClr val="F6693D"/>
-                </a:solidFill>
-                <a:latin typeface="Arial" pitchFamily="34" charset="0"/>
-                <a:ea typeface="Arial" pitchFamily="34" charset="-122"/>
-                <a:cs typeface="Arial" pitchFamily="34" charset="-120"/>
-              </a:rPr>
-              <a:t>THE GAP</a:t>
-            </a:r>
-            <a:endParaRPr lang="en-US" sz="900" dirty="0"/>
-          </a:p>
-        </p:txBody>
-      </p:sp>
-      <p:sp>
-        <p:nvSpPr>
-          <p:cNvPr id="15" name="Text 13"/>
-          <p:cNvSpPr/>
-          <p:nvPr/>
-        </p:nvSpPr>
-        <p:spPr>
-          <a:xfrm>
-            <a:off x="777240" y="3017520"/>
-            <a:ext cx="3657600" cy="384048"/>
-          </a:xfrm>
-          <a:prstGeom prst="rect">
-            <a:avLst/>
-          </a:prstGeom>
-          <a:noFill/>
-          <a:ln/>
-        </p:spPr>
-        <p:txBody>
-          <a:bodyPr wrap="square" lIns="0" tIns="0" rIns="0" bIns="0" rtlCol="0" anchor="t"/>
-          <a:lstStyle/>
-          <a:p>
-            <a:pPr indent="0" marL="0">
-              <a:buNone/>
-            </a:pPr>
-            <a:r>
-              <a:rPr lang="en-US" sz="1000" b="1" dirty="0">
-                <a:solidFill>
-                  <a:srgbClr val="F6693D"/>
-                </a:solidFill>
-                <a:latin typeface="Arial" pitchFamily="34" charset="0"/>
-                <a:ea typeface="Arial" pitchFamily="34" charset="-122"/>
-                <a:cs typeface="Arial" pitchFamily="34" charset="-120"/>
-              </a:rPr>
-              <a:t>—  </a:t>
-            </a:r>
-            <a:pPr indent="0" marL="0">
-              <a:buNone/>
-            </a:pPr>
-            <a:r>
-              <a:rPr lang="en-US" sz="1000" dirty="0">
-                <a:solidFill>
-                  <a:srgbClr val="CCCCCC"/>
-                </a:solidFill>
-                <a:latin typeface="Arial" pitchFamily="34" charset="0"/>
-                <a:ea typeface="Arial" pitchFamily="34" charset="-122"/>
-                <a:cs typeface="Arial" pitchFamily="34" charset="-120"/>
-              </a:rPr>
-              <a:t>Investors want guidance but won't pay for a financial advisor</a:t>
-            </a:r>
-            <a:endParaRPr lang="en-US" sz="1000" dirty="0"/>
-          </a:p>
-        </p:txBody>
-      </p:sp>
-      <p:sp>
-        <p:nvSpPr>
-          <p:cNvPr id="16" name="Text 14"/>
-          <p:cNvSpPr/>
-          <p:nvPr/>
-        </p:nvSpPr>
-        <p:spPr>
-          <a:xfrm>
-            <a:off x="777240" y="3429000"/>
-            <a:ext cx="3657600" cy="384048"/>
-          </a:xfrm>
-          <a:prstGeom prst="rect">
-            <a:avLst/>
-          </a:prstGeom>
-          <a:noFill/>
-          <a:ln/>
-        </p:spPr>
-        <p:txBody>
-          <a:bodyPr wrap="square" lIns="0" tIns="0" rIns="0" bIns="0" rtlCol="0" anchor="t"/>
-          <a:lstStyle/>
-          <a:p>
-            <a:pPr indent="0" marL="0">
-              <a:buNone/>
-            </a:pPr>
-            <a:r>
-              <a:rPr lang="en-US" sz="1000" b="1" dirty="0">
-                <a:solidFill>
-                  <a:srgbClr val="F6693D"/>
-                </a:solidFill>
-                <a:latin typeface="Arial" pitchFamily="34" charset="0"/>
-                <a:ea typeface="Arial" pitchFamily="34" charset="-122"/>
-                <a:cs typeface="Arial" pitchFamily="34" charset="-120"/>
-              </a:rPr>
-              <a:t>—  </a:t>
-            </a:r>
-            <a:pPr indent="0" marL="0">
-              <a:buNone/>
-            </a:pPr>
-            <a:r>
-              <a:rPr lang="en-US" sz="1000" dirty="0">
-                <a:solidFill>
-                  <a:srgbClr val="CCCCCC"/>
-                </a:solidFill>
-                <a:latin typeface="Arial" pitchFamily="34" charset="0"/>
-                <a:ea typeface="Arial" pitchFamily="34" charset="-122"/>
-                <a:cs typeface="Arial" pitchFamily="34" charset="-120"/>
-              </a:rPr>
-              <a:t>Existing tools offer product screeners, not portfolio construction</a:t>
-            </a:r>
-            <a:endParaRPr lang="en-US" sz="1000" dirty="0"/>
-          </a:p>
-        </p:txBody>
-      </p:sp>
-      <p:sp>
-        <p:nvSpPr>
-          <p:cNvPr id="17" name="Text 15"/>
-          <p:cNvSpPr/>
-          <p:nvPr/>
-        </p:nvSpPr>
-        <p:spPr>
-          <a:xfrm>
-            <a:off x="777240" y="3840480"/>
-            <a:ext cx="3657600" cy="384048"/>
-          </a:xfrm>
-          <a:prstGeom prst="rect">
-            <a:avLst/>
-          </a:prstGeom>
-          <a:noFill/>
-          <a:ln/>
-        </p:spPr>
-        <p:txBody>
-          <a:bodyPr wrap="square" lIns="0" tIns="0" rIns="0" bIns="0" rtlCol="0" anchor="t"/>
-          <a:lstStyle/>
-          <a:p>
-            <a:pPr indent="0" marL="0">
-              <a:buNone/>
-            </a:pPr>
-            <a:r>
-              <a:rPr lang="en-US" sz="1000" b="1" dirty="0">
-                <a:solidFill>
-                  <a:srgbClr val="F6693D"/>
-                </a:solidFill>
-                <a:latin typeface="Arial" pitchFamily="34" charset="0"/>
-                <a:ea typeface="Arial" pitchFamily="34" charset="-122"/>
-                <a:cs typeface="Arial" pitchFamily="34" charset="-120"/>
-              </a:rPr>
-              <a:t>—  </a:t>
-            </a:r>
-            <a:pPr indent="0" marL="0">
-              <a:buNone/>
-            </a:pPr>
-            <a:r>
-              <a:rPr lang="en-US" sz="1000" dirty="0">
-                <a:solidFill>
-                  <a:srgbClr val="CCCCCC"/>
-                </a:solidFill>
-                <a:latin typeface="Arial" pitchFamily="34" charset="0"/>
-                <a:ea typeface="Arial" pitchFamily="34" charset="-122"/>
-                <a:cs typeface="Arial" pitchFamily="34" charset="-120"/>
-              </a:rPr>
-              <a:t>Schwab, Vanguard, and Wealthfront are racing to own this layer</a:t>
-            </a:r>
-            <a:endParaRPr lang="en-US" sz="1000" dirty="0"/>
-          </a:p>
-        </p:txBody>
-      </p:sp>
-      <p:sp>
-        <p:nvSpPr>
-          <p:cNvPr id="18" name="Text 16"/>
-          <p:cNvSpPr/>
-          <p:nvPr/>
-        </p:nvSpPr>
-        <p:spPr>
-          <a:xfrm>
-            <a:off x="4846320" y="2697480"/>
-            <a:ext cx="3657600" cy="274320"/>
-          </a:xfrm>
-          <a:prstGeom prst="rect">
-            <a:avLst/>
-          </a:prstGeom>
-          <a:noFill/>
-          <a:ln/>
-        </p:spPr>
-        <p:txBody>
-          <a:bodyPr wrap="square" lIns="0" tIns="0" rIns="0" bIns="0" rtlCol="0" anchor="ctr"/>
-          <a:lstStyle/>
-          <a:p>
-            <a:pPr indent="0" marL="0">
-              <a:buNone/>
-            </a:pPr>
-            <a:r>
-              <a:rPr lang="en-US" sz="900" b="1" dirty="0">
-                <a:solidFill>
-                  <a:srgbClr val="00A854"/>
-                </a:solidFill>
-                <a:latin typeface="Arial" pitchFamily="34" charset="0"/>
-                <a:ea typeface="Arial" pitchFamily="34" charset="-122"/>
-                <a:cs typeface="Arial" pitchFamily="34" charset="-120"/>
-              </a:rPr>
-              <a:t>THE ISHARES ADVANTAGE</a:t>
-            </a:r>
-            <a:endParaRPr lang="en-US" sz="900" dirty="0"/>
-          </a:p>
-        </p:txBody>
-      </p:sp>
-      <p:sp>
-        <p:nvSpPr>
           <p:cNvPr id="19" name="Text 17"/>
-          <p:cNvSpPr/>
-          <p:nvPr/>
-        </p:nvSpPr>
-        <p:spPr>
-          <a:xfrm>
-            <a:off x="4846320" y="3017520"/>
-            <a:ext cx="3657600" cy="384048"/>
-          </a:xfrm>
-          <a:prstGeom prst="rect">
-            <a:avLst/>
-          </a:prstGeom>
-          <a:noFill/>
-          <a:ln/>
-        </p:spPr>
-        <p:txBody>
-          <a:bodyPr wrap="square" lIns="0" tIns="0" rIns="0" bIns="0" rtlCol="0" anchor="t"/>
-          <a:lstStyle/>
-          <a:p>
-            <a:pPr indent="0" marL="0">
-              <a:buNone/>
-            </a:pPr>
-            <a:r>
-              <a:rPr lang="en-US" sz="1000" b="1" dirty="0">
-                <a:solidFill>
-                  <a:srgbClr val="00A854"/>
-                </a:solidFill>
-                <a:latin typeface="Arial" pitchFamily="34" charset="0"/>
-                <a:ea typeface="Arial" pitchFamily="34" charset="-122"/>
-                <a:cs typeface="Arial" pitchFamily="34" charset="-120"/>
-              </a:rPr>
-              <a:t>+  </a:t>
-            </a:r>
-            <a:pPr indent="0" marL="0">
-              <a:buNone/>
-            </a:pPr>
-            <a:r>
-              <a:rPr lang="en-US" sz="1000" dirty="0">
-                <a:solidFill>
-                  <a:srgbClr val="CCCCCC"/>
-                </a:solidFill>
-                <a:latin typeface="Arial" pitchFamily="34" charset="0"/>
-                <a:ea typeface="Arial" pitchFamily="34" charset="-122"/>
-                <a:cs typeface="Arial" pitchFamily="34" charset="-120"/>
-              </a:rPr>
-              <a:t>Broadest ETF lineup — index, active, factor, thematic</a:t>
-            </a:r>
-            <a:endParaRPr lang="en-US" sz="1000" dirty="0"/>
-          </a:p>
-        </p:txBody>
-      </p:sp>
-      <p:sp>
-        <p:nvSpPr>
-          <p:cNvPr id="20" name="Text 18"/>
-          <p:cNvSpPr/>
-          <p:nvPr/>
-        </p:nvSpPr>
-        <p:spPr>
-          <a:xfrm>
-            <a:off x="4846320" y="3429000"/>
-            <a:ext cx="3657600" cy="384048"/>
-          </a:xfrm>
-          <a:prstGeom prst="rect">
-            <a:avLst/>
-          </a:prstGeom>
-          <a:noFill/>
-          <a:ln/>
-        </p:spPr>
-        <p:txBody>
-          <a:bodyPr wrap="square" lIns="0" tIns="0" rIns="0" bIns="0" rtlCol="0" anchor="t"/>
-          <a:lstStyle/>
-          <a:p>
-            <a:pPr indent="0" marL="0">
-              <a:buNone/>
-            </a:pPr>
-            <a:r>
-              <a:rPr lang="en-US" sz="1000" b="1" dirty="0">
-                <a:solidFill>
-                  <a:srgbClr val="00A854"/>
-                </a:solidFill>
-                <a:latin typeface="Arial" pitchFamily="34" charset="0"/>
-                <a:ea typeface="Arial" pitchFamily="34" charset="-122"/>
-                <a:cs typeface="Arial" pitchFamily="34" charset="-120"/>
-              </a:rPr>
-              <a:t>+  </a:t>
-            </a:r>
-            <a:pPr indent="0" marL="0">
-              <a:buNone/>
-            </a:pPr>
-            <a:r>
-              <a:rPr lang="en-US" sz="1000" dirty="0">
-                <a:solidFill>
-                  <a:srgbClr val="CCCCCC"/>
-                </a:solidFill>
-                <a:latin typeface="Arial" pitchFamily="34" charset="0"/>
-                <a:ea typeface="Arial" pitchFamily="34" charset="-122"/>
-                <a:cs typeface="Arial" pitchFamily="34" charset="-120"/>
-              </a:rPr>
-              <a:t>BlackRock Investment Institute capital market assumptions</a:t>
-            </a:r>
-            <a:endParaRPr lang="en-US" sz="1000" dirty="0"/>
-          </a:p>
-        </p:txBody>
-      </p:sp>
-      <p:sp>
-        <p:nvSpPr>
-          <p:cNvPr id="21" name="Text 19"/>
-          <p:cNvSpPr/>
-          <p:nvPr/>
-        </p:nvSpPr>
-        <p:spPr>
-          <a:xfrm>
-            <a:off x="4846320" y="3840480"/>
-            <a:ext cx="3657600" cy="384048"/>
-          </a:xfrm>
-          <a:prstGeom prst="rect">
-            <a:avLst/>
-          </a:prstGeom>
-          <a:noFill/>
-          <a:ln/>
-        </p:spPr>
-        <p:txBody>
-          <a:bodyPr wrap="square" lIns="0" tIns="0" rIns="0" bIns="0" rtlCol="0" anchor="t"/>
-          <a:lstStyle/>
-          <a:p>
-            <a:pPr indent="0" marL="0">
-              <a:buNone/>
-            </a:pPr>
-            <a:r>
-              <a:rPr lang="en-US" sz="1000" b="1" dirty="0">
-                <a:solidFill>
-                  <a:srgbClr val="00A854"/>
-                </a:solidFill>
-                <a:latin typeface="Arial" pitchFamily="34" charset="0"/>
-                <a:ea typeface="Arial" pitchFamily="34" charset="-122"/>
-                <a:cs typeface="Arial" pitchFamily="34" charset="-120"/>
-              </a:rPr>
-              <a:t>+  </a:t>
-            </a:r>
-            <a:pPr indent="0" marL="0">
-              <a:buNone/>
-            </a:pPr>
-            <a:r>
-              <a:rPr lang="en-US" sz="1000" dirty="0">
-                <a:solidFill>
-                  <a:srgbClr val="CCCCCC"/>
-                </a:solidFill>
-                <a:latin typeface="Arial" pitchFamily="34" charset="0"/>
-                <a:ea typeface="Arial" pitchFamily="34" charset="-122"/>
-                <a:cs typeface="Arial" pitchFamily="34" charset="-120"/>
-              </a:rPr>
-              <a:t>Trusted brand with institutional credibility at scale</a:t>
-            </a:r>
-            <a:endParaRPr lang="en-US" sz="1000" dirty="0"/>
-          </a:p>
-        </p:txBody>
-      </p:sp>
-      <p:sp>
-        <p:nvSpPr>
-          <p:cNvPr id="22" name="Text 20"/>
-          <p:cNvSpPr/>
-          <p:nvPr/>
-        </p:nvSpPr>
-        <p:spPr>
-          <a:xfrm>
-            <a:off x="457200" y="4160520"/>
-            <a:ext cx="8229600" cy="502920"/>
-          </a:xfrm>
-          <a:prstGeom prst="rect">
-            <a:avLst/>
-          </a:prstGeom>
-          <a:noFill/>
-          <a:ln/>
-        </p:spPr>
-        <p:txBody>
-          <a:bodyPr wrap="square" lIns="0" tIns="0" rIns="0" bIns="0" rtlCol="0" anchor="t"/>
-          <a:lstStyle/>
-          <a:p>
-            <a:pPr indent="0" marL="0">
-              <a:buNone/>
-            </a:pPr>
-            <a:r>
-              <a:rPr lang="en-US" sz="700" dirty="0">
-                <a:solidFill>
-                  <a:srgbClr val="999999"/>
-                </a:solidFill>
-                <a:latin typeface="Arial" pitchFamily="34" charset="0"/>
-                <a:ea typeface="Arial" pitchFamily="34" charset="-122"/>
-                <a:cs typeface="Arial" pitchFamily="34" charset="-120"/>
-              </a:rPr>
-              <a:t>Source: BlackRock (US AUM, ETF count as of Q1 2026). Self-directed accounts: Cerulli Associates.</a:t>
-            </a:r>
-            <a:endParaRPr lang="en-US" sz="700" dirty="0"/>
-          </a:p>
-        </p:txBody>
-      </p:sp>
-      <p:sp>
-        <p:nvSpPr>
-          <p:cNvPr id="23" name="Shape 21"/>
-          <p:cNvSpPr/>
-          <p:nvPr/>
-        </p:nvSpPr>
-        <p:spPr>
-          <a:xfrm>
-            <a:off x="0" y="4526280"/>
-            <a:ext cx="9144000" cy="617220"/>
-          </a:xfrm>
-          <a:prstGeom prst="rect">
-            <a:avLst/>
-          </a:prstGeom>
-          <a:solidFill>
-            <a:srgbClr val="333333"/>
-          </a:solidFill>
-          <a:ln/>
-        </p:spPr>
-      </p:sp>
-      <p:sp>
-        <p:nvSpPr>
-          <p:cNvPr id="24" name="Text 22"/>
           <p:cNvSpPr/>
           <p:nvPr/>
         </p:nvSpPr>
@@ -1919,7 +1663,7 @@
       </p:sp>
       <p:sp>
         <p:nvSpPr>
-          <p:cNvPr id="25" name="Text 23"/>
+          <p:cNvPr id="20" name="Text 18"/>
           <p:cNvSpPr/>
           <p:nvPr/>
         </p:nvSpPr>

</xml_diff>

<commit_message>
Simplify slide 1: remove stats, clean layout with yellow accent bar
Co-Authored-By: Claude Opus 4.6 <noreply@anthropic.com>
</commit_message>
<xml_diff>
--- a/public/deck/iShares_Direct_Personalization_2_Slides.pptx
+++ b/public/deck/iShares_Direct_Personalization_2_Slides.pptx
@@ -966,7 +966,7 @@
         <p:spPr>
           <a:xfrm>
             <a:off x="0" y="0"/>
-            <a:ext cx="9144000" cy="73152"/>
+            <a:ext cx="109728" cy="5143500"/>
           </a:xfrm>
           <a:prstGeom prst="rect">
             <a:avLst/>
@@ -985,8 +985,8 @@
         </p:nvSpPr>
         <p:spPr>
           <a:xfrm>
-            <a:off x="457200" y="182880"/>
-            <a:ext cx="6583680" cy="640080"/>
+            <a:off x="548640" y="457200"/>
+            <a:ext cx="7772400" cy="1280160"/>
           </a:xfrm>
           <a:prstGeom prst="rect">
             <a:avLst/>
@@ -999,10 +999,13 @@
           <a:lstStyle/>
           <a:p>
             <a:pPr indent="0" marL="0">
-              <a:buNone/>
-            </a:pPr>
-            <a:r>
-              <a:rPr lang="en-US" sz="2700" b="1" dirty="0">
+              <a:lnSpc>
+                <a:spcPct val="110000"/>
+              </a:lnSpc>
+              <a:buNone/>
+            </a:pPr>
+            <a:r>
+              <a:rPr lang="en-US" sz="3400" b="1" dirty="0">
                 <a:solidFill>
                   <a:srgbClr val="000000"/>
                 </a:solidFill>
@@ -1010,9 +1013,29 @@
                 <a:ea typeface="Arial Black" pitchFamily="34" charset="-122"/>
                 <a:cs typeface="Arial Black" pitchFamily="34" charset="-120"/>
               </a:rPr>
-              <a:t>iShares Can Own the Personalization Layer</a:t>
-            </a:r>
-            <a:endParaRPr lang="en-US" sz="2700" dirty="0"/>
+              <a:t>From ETF Provider</a:t>
+            </a:r>
+            <a:endParaRPr lang="en-US" sz="3400" dirty="0"/>
+          </a:p>
+          <a:p>
+            <a:pPr indent="0" marL="0">
+              <a:lnSpc>
+                <a:spcPct val="110000"/>
+              </a:lnSpc>
+              <a:buNone/>
+            </a:pPr>
+            <a:r>
+              <a:rPr lang="en-US" sz="3400" b="1" dirty="0">
+                <a:solidFill>
+                  <a:srgbClr val="000000"/>
+                </a:solidFill>
+                <a:latin typeface="Arial Black" pitchFamily="34" charset="0"/>
+                <a:ea typeface="Arial Black" pitchFamily="34" charset="-122"/>
+                <a:cs typeface="Arial Black" pitchFamily="34" charset="-120"/>
+              </a:rPr>
+              <a:t>to Personalization Engine</a:t>
+            </a:r>
+            <a:endParaRPr lang="en-US" sz="3400" dirty="0"/>
           </a:p>
         </p:txBody>
       </p:sp>
@@ -1024,8 +1047,8 @@
         </p:nvSpPr>
         <p:spPr>
           <a:xfrm>
-            <a:off x="457200" y="777240"/>
-            <a:ext cx="8229600" cy="548640"/>
+            <a:off x="548640" y="1828800"/>
+            <a:ext cx="7315200" cy="548640"/>
           </a:xfrm>
           <a:prstGeom prst="rect">
             <a:avLst/>
@@ -1041,7 +1064,7 @@
               <a:buNone/>
             </a:pPr>
             <a:r>
-              <a:rPr lang="en-US" sz="1350" dirty="0">
+              <a:rPr lang="en-US" sz="1400" dirty="0">
                 <a:solidFill>
                   <a:srgbClr val="666666"/>
                 </a:solidFill>
@@ -1049,9 +1072,9 @@
                 <a:ea typeface="Arial" pitchFamily="34" charset="-122"/>
                 <a:cs typeface="Arial" pitchFamily="34" charset="-120"/>
               </a:rPr>
-              <a:t>75M+ self-directed investors want portfolio guidance — not just product access. iShares has the scale, lineup, and brand to deliver it.</a:t>
-            </a:r>
-            <a:endParaRPr lang="en-US" sz="1350" dirty="0"/>
+              <a:t>iShares has the scale, lineup, and brand to guide self-directed investors from product selection to personalized portfolios.</a:t>
+            </a:r>
+            <a:endParaRPr lang="en-US" sz="1400" dirty="0"/>
           </a:p>
         </p:txBody>
       </p:sp>
@@ -1063,16 +1086,16 @@
         </p:nvSpPr>
         <p:spPr>
           <a:xfrm>
-            <a:off x="457200" y="2468880"/>
-            <a:ext cx="8229600" cy="0"/>
+            <a:off x="548640" y="2514600"/>
+            <a:ext cx="2743200" cy="0"/>
           </a:xfrm>
           <a:prstGeom prst="line">
             <a:avLst/>
           </a:prstGeom>
           <a:noFill/>
-          <a:ln w="12700">
+          <a:ln w="38100">
             <a:solidFill>
-              <a:srgbClr val="E5E5E5"/>
+              <a:srgbClr val="FFD100"/>
             </a:solidFill>
             <a:prstDash val="solid"/>
           </a:ln>
@@ -1086,34 +1109,34 @@
         </p:nvSpPr>
         <p:spPr>
           <a:xfrm>
-            <a:off x="457200" y="1417320"/>
-            <a:ext cx="2743200" cy="594360"/>
-          </a:xfrm>
-          <a:prstGeom prst="rect">
-            <a:avLst/>
-          </a:prstGeom>
-          <a:noFill/>
-          <a:ln/>
-        </p:spPr>
-        <p:txBody>
-          <a:bodyPr wrap="square" lIns="0" tIns="0" rIns="0" bIns="0" rtlCol="0" anchor="ctr"/>
-          <a:lstStyle/>
-          <a:p>
-            <a:pPr algn="ctr" indent="0" marL="0">
-              <a:buNone/>
-            </a:pPr>
-            <a:r>
-              <a:rPr lang="en-US" sz="4000" b="1" dirty="0">
-                <a:solidFill>
-                  <a:srgbClr val="F6693D"/>
-                </a:solidFill>
-                <a:latin typeface="Arial Black" pitchFamily="34" charset="0"/>
-                <a:ea typeface="Arial Black" pitchFamily="34" charset="-122"/>
-                <a:cs typeface="Arial Black" pitchFamily="34" charset="-120"/>
-              </a:rPr>
-              <a:t>$3.9T+</a:t>
-            </a:r>
-            <a:endParaRPr lang="en-US" sz="4000" dirty="0"/>
+            <a:off x="548640" y="2788920"/>
+            <a:ext cx="7772400" cy="438912"/>
+          </a:xfrm>
+          <a:prstGeom prst="rect">
+            <a:avLst/>
+          </a:prstGeom>
+          <a:noFill/>
+          <a:ln/>
+        </p:spPr>
+        <p:txBody>
+          <a:bodyPr wrap="square" lIns="0" tIns="0" rIns="0" bIns="0" rtlCol="0" anchor="t"/>
+          <a:lstStyle/>
+          <a:p>
+            <a:pPr indent="0" marL="0">
+              <a:buNone/>
+            </a:pPr>
+            <a:r>
+              <a:rPr lang="en-US" sz="1200" dirty="0">
+                <a:solidFill>
+                  <a:srgbClr val="333333"/>
+                </a:solidFill>
+                <a:latin typeface="Arial" pitchFamily="34" charset="0"/>
+                <a:ea typeface="Arial" pitchFamily="34" charset="-122"/>
+                <a:cs typeface="Arial" pitchFamily="34" charset="-120"/>
+              </a:rPr>
+              <a:t>75M+ self-directed investors want guidance but won't pay for an advisor — they need a product-embedded solution.</a:t>
+            </a:r>
+            <a:endParaRPr lang="en-US" sz="1200" dirty="0"/>
           </a:p>
         </p:txBody>
       </p:sp>
@@ -1125,34 +1148,34 @@
         </p:nvSpPr>
         <p:spPr>
           <a:xfrm>
-            <a:off x="457200" y="1965960"/>
-            <a:ext cx="2743200" cy="365760"/>
-          </a:xfrm>
-          <a:prstGeom prst="rect">
-            <a:avLst/>
-          </a:prstGeom>
-          <a:noFill/>
-          <a:ln/>
-        </p:spPr>
-        <p:txBody>
-          <a:bodyPr wrap="square" lIns="0" tIns="0" rIns="0" bIns="0" rtlCol="0" anchor="ctr"/>
-          <a:lstStyle/>
-          <a:p>
-            <a:pPr algn="ctr" indent="0" marL="0">
-              <a:buNone/>
-            </a:pPr>
-            <a:r>
-              <a:rPr lang="en-US" sz="1100" dirty="0">
-                <a:solidFill>
-                  <a:srgbClr val="666666"/>
-                </a:solidFill>
-                <a:latin typeface="Arial" pitchFamily="34" charset="0"/>
-                <a:ea typeface="Arial" pitchFamily="34" charset="-122"/>
-                <a:cs typeface="Arial" pitchFamily="34" charset="-120"/>
-              </a:rPr>
-              <a:t>US AUM</a:t>
-            </a:r>
-            <a:endParaRPr lang="en-US" sz="1100" dirty="0"/>
+            <a:off x="548640" y="3246120"/>
+            <a:ext cx="7772400" cy="438912"/>
+          </a:xfrm>
+          <a:prstGeom prst="rect">
+            <a:avLst/>
+          </a:prstGeom>
+          <a:noFill/>
+          <a:ln/>
+        </p:spPr>
+        <p:txBody>
+          <a:bodyPr wrap="square" lIns="0" tIns="0" rIns="0" bIns="0" rtlCol="0" anchor="t"/>
+          <a:lstStyle/>
+          <a:p>
+            <a:pPr indent="0" marL="0">
+              <a:buNone/>
+            </a:pPr>
+            <a:r>
+              <a:rPr lang="en-US" sz="1200" dirty="0">
+                <a:solidFill>
+                  <a:srgbClr val="333333"/>
+                </a:solidFill>
+                <a:latin typeface="Arial" pitchFamily="34" charset="0"/>
+                <a:ea typeface="Arial" pitchFamily="34" charset="-122"/>
+                <a:cs typeface="Arial" pitchFamily="34" charset="-120"/>
+              </a:rPr>
+              <a:t>Schwab, Vanguard, and Wealthfront are racing to own the personalization layer. iShares isn't in the race yet.</a:t>
+            </a:r>
+            <a:endParaRPr lang="en-US" sz="1200" dirty="0"/>
           </a:p>
         </p:txBody>
       </p:sp>
@@ -1164,203 +1187,8 @@
         </p:nvSpPr>
         <p:spPr>
           <a:xfrm>
-            <a:off x="3200400" y="1417320"/>
-            <a:ext cx="2743200" cy="594360"/>
-          </a:xfrm>
-          <a:prstGeom prst="rect">
-            <a:avLst/>
-          </a:prstGeom>
-          <a:noFill/>
-          <a:ln/>
-        </p:spPr>
-        <p:txBody>
-          <a:bodyPr wrap="square" lIns="0" tIns="0" rIns="0" bIns="0" rtlCol="0" anchor="ctr"/>
-          <a:lstStyle/>
-          <a:p>
-            <a:pPr algn="ctr" indent="0" marL="0">
-              <a:buNone/>
-            </a:pPr>
-            <a:r>
-              <a:rPr lang="en-US" sz="4000" b="1" dirty="0">
-                <a:solidFill>
-                  <a:srgbClr val="F6693D"/>
-                </a:solidFill>
-                <a:latin typeface="Arial Black" pitchFamily="34" charset="0"/>
-                <a:ea typeface="Arial Black" pitchFamily="34" charset="-122"/>
-                <a:cs typeface="Arial Black" pitchFamily="34" charset="-120"/>
-              </a:rPr>
-              <a:t>430+</a:t>
-            </a:r>
-            <a:endParaRPr lang="en-US" sz="4000" dirty="0"/>
-          </a:p>
-        </p:txBody>
-      </p:sp>
-      <p:sp>
-        <p:nvSpPr>
-          <p:cNvPr id="9" name="Text 7"/>
-          <p:cNvSpPr/>
-          <p:nvPr/>
-        </p:nvSpPr>
-        <p:spPr>
-          <a:xfrm>
-            <a:off x="3200400" y="1965960"/>
-            <a:ext cx="2743200" cy="365760"/>
-          </a:xfrm>
-          <a:prstGeom prst="rect">
-            <a:avLst/>
-          </a:prstGeom>
-          <a:noFill/>
-          <a:ln/>
-        </p:spPr>
-        <p:txBody>
-          <a:bodyPr wrap="square" lIns="0" tIns="0" rIns="0" bIns="0" rtlCol="0" anchor="ctr"/>
-          <a:lstStyle/>
-          <a:p>
-            <a:pPr algn="ctr" indent="0" marL="0">
-              <a:buNone/>
-            </a:pPr>
-            <a:r>
-              <a:rPr lang="en-US" sz="1100" dirty="0">
-                <a:solidFill>
-                  <a:srgbClr val="666666"/>
-                </a:solidFill>
-                <a:latin typeface="Arial" pitchFamily="34" charset="0"/>
-                <a:ea typeface="Arial" pitchFamily="34" charset="-122"/>
-                <a:cs typeface="Arial" pitchFamily="34" charset="-120"/>
-              </a:rPr>
-              <a:t>US-Listed ETFs</a:t>
-            </a:r>
-            <a:endParaRPr lang="en-US" sz="1100" dirty="0"/>
-          </a:p>
-        </p:txBody>
-      </p:sp>
-      <p:sp>
-        <p:nvSpPr>
-          <p:cNvPr id="10" name="Text 8"/>
-          <p:cNvSpPr/>
-          <p:nvPr/>
-        </p:nvSpPr>
-        <p:spPr>
-          <a:xfrm>
-            <a:off x="5943600" y="1417320"/>
-            <a:ext cx="2743200" cy="594360"/>
-          </a:xfrm>
-          <a:prstGeom prst="rect">
-            <a:avLst/>
-          </a:prstGeom>
-          <a:noFill/>
-          <a:ln/>
-        </p:spPr>
-        <p:txBody>
-          <a:bodyPr wrap="square" lIns="0" tIns="0" rIns="0" bIns="0" rtlCol="0" anchor="ctr"/>
-          <a:lstStyle/>
-          <a:p>
-            <a:pPr algn="ctr" indent="0" marL="0">
-              <a:buNone/>
-            </a:pPr>
-            <a:r>
-              <a:rPr lang="en-US" sz="4000" b="1" dirty="0">
-                <a:solidFill>
-                  <a:srgbClr val="F6693D"/>
-                </a:solidFill>
-                <a:latin typeface="Arial Black" pitchFamily="34" charset="0"/>
-                <a:ea typeface="Arial Black" pitchFamily="34" charset="-122"/>
-                <a:cs typeface="Arial Black" pitchFamily="34" charset="-120"/>
-              </a:rPr>
-              <a:t>75M+</a:t>
-            </a:r>
-            <a:endParaRPr lang="en-US" sz="4000" dirty="0"/>
-          </a:p>
-        </p:txBody>
-      </p:sp>
-      <p:sp>
-        <p:nvSpPr>
-          <p:cNvPr id="11" name="Text 9"/>
-          <p:cNvSpPr/>
-          <p:nvPr/>
-        </p:nvSpPr>
-        <p:spPr>
-          <a:xfrm>
-            <a:off x="5943600" y="1965960"/>
-            <a:ext cx="2743200" cy="365760"/>
-          </a:xfrm>
-          <a:prstGeom prst="rect">
-            <a:avLst/>
-          </a:prstGeom>
-          <a:noFill/>
-          <a:ln/>
-        </p:spPr>
-        <p:txBody>
-          <a:bodyPr wrap="square" lIns="0" tIns="0" rIns="0" bIns="0" rtlCol="0" anchor="ctr"/>
-          <a:lstStyle/>
-          <a:p>
-            <a:pPr algn="ctr" indent="0" marL="0">
-              <a:buNone/>
-            </a:pPr>
-            <a:r>
-              <a:rPr lang="en-US" sz="1100" dirty="0">
-                <a:solidFill>
-                  <a:srgbClr val="666666"/>
-                </a:solidFill>
-                <a:latin typeface="Arial" pitchFamily="34" charset="0"/>
-                <a:ea typeface="Arial" pitchFamily="34" charset="-122"/>
-                <a:cs typeface="Arial" pitchFamily="34" charset="-120"/>
-              </a:rPr>
-              <a:t>Self-Directed Accounts</a:t>
-            </a:r>
-            <a:endParaRPr lang="en-US" sz="1100" dirty="0"/>
-          </a:p>
-        </p:txBody>
-      </p:sp>
-      <p:sp>
-        <p:nvSpPr>
-          <p:cNvPr id="12" name="Text 10"/>
-          <p:cNvSpPr/>
-          <p:nvPr/>
-        </p:nvSpPr>
-        <p:spPr>
-          <a:xfrm>
-            <a:off x="457200" y="2606040"/>
-            <a:ext cx="8229600" cy="274320"/>
-          </a:xfrm>
-          <a:prstGeom prst="rect">
-            <a:avLst/>
-          </a:prstGeom>
-          <a:noFill/>
-          <a:ln/>
-        </p:spPr>
-        <p:txBody>
-          <a:bodyPr wrap="square" lIns="0" tIns="0" rIns="0" bIns="0" rtlCol="0" anchor="ctr"/>
-          <a:lstStyle/>
-          <a:p>
-            <a:pPr indent="0" marL="0">
-              <a:buNone/>
-            </a:pPr>
-            <a:r>
-              <a:rPr lang="en-US" sz="900" b="1" dirty="0">
-                <a:solidFill>
-                  <a:srgbClr val="F6693D"/>
-                </a:solidFill>
-                <a:latin typeface="Arial" pitchFamily="34" charset="0"/>
-                <a:ea typeface="Arial" pitchFamily="34" charset="-122"/>
-                <a:cs typeface="Arial" pitchFamily="34" charset="-120"/>
-              </a:rPr>
-              <a:t>THE OPPORTUNITY</a:t>
-            </a:r>
-            <a:endParaRPr lang="en-US" sz="900" dirty="0"/>
-          </a:p>
-        </p:txBody>
-      </p:sp>
-      <p:sp>
-        <p:nvSpPr>
-          <p:cNvPr id="13" name="Text 11"/>
-          <p:cNvSpPr/>
-          <p:nvPr/>
-        </p:nvSpPr>
-        <p:spPr>
-          <a:xfrm>
-            <a:off x="457200" y="2926080"/>
-            <a:ext cx="8229600" cy="329184"/>
+            <a:off x="548640" y="3703320"/>
+            <a:ext cx="7772400" cy="438912"/>
           </a:xfrm>
           <a:prstGeom prst="rect">
             <a:avLst/>
@@ -1376,21 +1204,7 @@
               <a:buNone/>
             </a:pPr>
             <a:r>
-              <a:rPr lang="en-US" sz="1050" b="1" dirty="0">
-                <a:solidFill>
-                  <a:srgbClr val="F6693D"/>
-                </a:solidFill>
-                <a:latin typeface="Arial" pitchFamily="34" charset="0"/>
-                <a:ea typeface="Arial" pitchFamily="34" charset="-122"/>
-                <a:cs typeface="Arial" pitchFamily="34" charset="-120"/>
-              </a:rPr>
-              <a:t>—  </a:t>
-            </a:r>
-            <a:pPr indent="0" marL="0">
-              <a:buNone/>
-            </a:pPr>
-            <a:r>
-              <a:rPr lang="en-US" sz="1050" dirty="0">
+              <a:rPr lang="en-US" sz="1200" dirty="0">
                 <a:solidFill>
                   <a:srgbClr val="333333"/>
                 </a:solidFill>
@@ -1398,213 +1212,15 @@
                 <a:ea typeface="Arial" pitchFamily="34" charset="-122"/>
                 <a:cs typeface="Arial" pitchFamily="34" charset="-120"/>
               </a:rPr>
-              <a:t>Self-directed investors want guidance but won't pay for an advisor — they need a product-embedded solution</a:t>
-            </a:r>
-            <a:endParaRPr lang="en-US" sz="1050" dirty="0"/>
-          </a:p>
-        </p:txBody>
-      </p:sp>
-      <p:sp>
-        <p:nvSpPr>
-          <p:cNvPr id="14" name="Text 12"/>
-          <p:cNvSpPr/>
-          <p:nvPr/>
-        </p:nvSpPr>
-        <p:spPr>
-          <a:xfrm>
-            <a:off x="457200" y="3273552"/>
-            <a:ext cx="8229600" cy="329184"/>
-          </a:xfrm>
-          <a:prstGeom prst="rect">
-            <a:avLst/>
-          </a:prstGeom>
-          <a:noFill/>
-          <a:ln/>
-        </p:spPr>
-        <p:txBody>
-          <a:bodyPr wrap="square" lIns="0" tIns="0" rIns="0" bIns="0" rtlCol="0" anchor="t"/>
-          <a:lstStyle/>
-          <a:p>
-            <a:pPr indent="0" marL="0">
-              <a:buNone/>
-            </a:pPr>
-            <a:r>
-              <a:rPr lang="en-US" sz="1050" b="1" dirty="0">
-                <a:solidFill>
-                  <a:srgbClr val="F6693D"/>
-                </a:solidFill>
-                <a:latin typeface="Arial" pitchFamily="34" charset="0"/>
-                <a:ea typeface="Arial" pitchFamily="34" charset="-122"/>
-                <a:cs typeface="Arial" pitchFamily="34" charset="-120"/>
-              </a:rPr>
-              <a:t>—  </a:t>
-            </a:r>
-            <a:pPr indent="0" marL="0">
-              <a:buNone/>
-            </a:pPr>
-            <a:r>
-              <a:rPr lang="en-US" sz="1050" dirty="0">
-                <a:solidFill>
-                  <a:srgbClr val="333333"/>
-                </a:solidFill>
-                <a:latin typeface="Arial" pitchFamily="34" charset="0"/>
-                <a:ea typeface="Arial" pitchFamily="34" charset="-122"/>
-                <a:cs typeface="Arial" pitchFamily="34" charset="-120"/>
-              </a:rPr>
-              <a:t>Competitors (Schwab, Vanguard, Wealthfront) are racing to own this layer with robo-advisory tools</a:t>
-            </a:r>
-            <a:endParaRPr lang="en-US" sz="1050" dirty="0"/>
-          </a:p>
-        </p:txBody>
-      </p:sp>
-      <p:sp>
-        <p:nvSpPr>
-          <p:cNvPr id="15" name="Text 13"/>
-          <p:cNvSpPr/>
-          <p:nvPr/>
-        </p:nvSpPr>
-        <p:spPr>
-          <a:xfrm>
-            <a:off x="457200" y="3621024"/>
-            <a:ext cx="8229600" cy="329184"/>
-          </a:xfrm>
-          <a:prstGeom prst="rect">
-            <a:avLst/>
-          </a:prstGeom>
-          <a:noFill/>
-          <a:ln/>
-        </p:spPr>
-        <p:txBody>
-          <a:bodyPr wrap="square" lIns="0" tIns="0" rIns="0" bIns="0" rtlCol="0" anchor="t"/>
-          <a:lstStyle/>
-          <a:p>
-            <a:pPr indent="0" marL="0">
-              <a:buNone/>
-            </a:pPr>
-            <a:r>
-              <a:rPr lang="en-US" sz="1050" b="1" dirty="0">
-                <a:solidFill>
-                  <a:srgbClr val="00A854"/>
-                </a:solidFill>
-                <a:latin typeface="Arial" pitchFamily="34" charset="0"/>
-                <a:ea typeface="Arial" pitchFamily="34" charset="-122"/>
-                <a:cs typeface="Arial" pitchFamily="34" charset="-120"/>
-              </a:rPr>
-              <a:t>+  </a:t>
-            </a:r>
-            <a:pPr indent="0" marL="0">
-              <a:buNone/>
-            </a:pPr>
-            <a:r>
-              <a:rPr lang="en-US" sz="1050" dirty="0">
-                <a:solidFill>
-                  <a:srgbClr val="333333"/>
-                </a:solidFill>
-                <a:latin typeface="Arial" pitchFamily="34" charset="0"/>
-                <a:ea typeface="Arial" pitchFamily="34" charset="-122"/>
-                <a:cs typeface="Arial" pitchFamily="34" charset="-120"/>
-              </a:rPr>
-              <a:t>iShares has the broadest ETF lineup, BII capital market assumptions, and institutional credibility to win</a:t>
-            </a:r>
-            <a:endParaRPr lang="en-US" sz="1050" dirty="0"/>
-          </a:p>
-        </p:txBody>
-      </p:sp>
-      <p:sp>
-        <p:nvSpPr>
-          <p:cNvPr id="16" name="Text 14"/>
-          <p:cNvSpPr/>
-          <p:nvPr/>
-        </p:nvSpPr>
-        <p:spPr>
-          <a:xfrm>
-            <a:off x="457200" y="3968496"/>
-            <a:ext cx="8229600" cy="329184"/>
-          </a:xfrm>
-          <a:prstGeom prst="rect">
-            <a:avLst/>
-          </a:prstGeom>
-          <a:noFill/>
-          <a:ln/>
-        </p:spPr>
-        <p:txBody>
-          <a:bodyPr wrap="square" lIns="0" tIns="0" rIns="0" bIns="0" rtlCol="0" anchor="t"/>
-          <a:lstStyle/>
-          <a:p>
-            <a:pPr indent="0" marL="0">
-              <a:buNone/>
-            </a:pPr>
-            <a:r>
-              <a:rPr lang="en-US" sz="1050" b="1" dirty="0">
-                <a:solidFill>
-                  <a:srgbClr val="00A854"/>
-                </a:solidFill>
-                <a:latin typeface="Arial" pitchFamily="34" charset="0"/>
-                <a:ea typeface="Arial" pitchFamily="34" charset="-122"/>
-                <a:cs typeface="Arial" pitchFamily="34" charset="-120"/>
-              </a:rPr>
-              <a:t>+  </a:t>
-            </a:r>
-            <a:pPr indent="0" marL="0">
-              <a:buNone/>
-            </a:pPr>
-            <a:r>
-              <a:rPr lang="en-US" sz="1050" dirty="0">
-                <a:solidFill>
-                  <a:srgbClr val="333333"/>
-                </a:solidFill>
-                <a:latin typeface="Arial" pitchFamily="34" charset="0"/>
-                <a:ea typeface="Arial" pitchFamily="34" charset="-122"/>
-                <a:cs typeface="Arial" pitchFamily="34" charset="-120"/>
-              </a:rPr>
-              <a:t>The path: start with simple allocation models, layer in AI-driven personalization over time</a:t>
-            </a:r>
-            <a:endParaRPr lang="en-US" sz="1050" dirty="0"/>
-          </a:p>
-        </p:txBody>
-      </p:sp>
-      <p:sp>
-        <p:nvSpPr>
-          <p:cNvPr id="17" name="Text 15"/>
-          <p:cNvSpPr/>
-          <p:nvPr/>
-        </p:nvSpPr>
-        <p:spPr>
-          <a:xfrm>
-            <a:off x="457200" y="4160520"/>
-            <a:ext cx="8229600" cy="502920"/>
-          </a:xfrm>
-          <a:prstGeom prst="rect">
-            <a:avLst/>
-          </a:prstGeom>
-          <a:noFill/>
-          <a:ln/>
-        </p:spPr>
-        <p:txBody>
-          <a:bodyPr wrap="square" lIns="0" tIns="0" rIns="0" bIns="0" rtlCol="0" anchor="t"/>
-          <a:lstStyle/>
-          <a:p>
-            <a:pPr indent="0" marL="0">
-              <a:buNone/>
-            </a:pPr>
-            <a:r>
-              <a:rPr lang="en-US" sz="700" dirty="0">
-                <a:solidFill>
-                  <a:srgbClr val="999999"/>
-                </a:solidFill>
-                <a:latin typeface="Arial" pitchFamily="34" charset="0"/>
-                <a:ea typeface="Arial" pitchFamily="34" charset="-122"/>
-                <a:cs typeface="Arial" pitchFamily="34" charset="-120"/>
-              </a:rPr>
-              <a:t>Source: BlackRock (US AUM, ETF count as of Q1 2026). Self-directed accounts: Cerulli Associates.</a:t>
-            </a:r>
-            <a:endParaRPr lang="en-US" sz="700" dirty="0"/>
-          </a:p>
-        </p:txBody>
-      </p:sp>
-      <p:sp>
-        <p:nvSpPr>
-          <p:cNvPr id="18" name="Shape 16"/>
+              <a:t>The path forward: start with simple allocation models, then layer in AI-driven personalization over time.</a:t>
+            </a:r>
+            <a:endParaRPr lang="en-US" sz="1200" dirty="0"/>
+          </a:p>
+        </p:txBody>
+      </p:sp>
+      <p:sp>
+        <p:nvSpPr>
+          <p:cNvPr id="9" name="Shape 7"/>
           <p:cNvSpPr/>
           <p:nvPr/>
         </p:nvSpPr>
@@ -1624,7 +1240,7 @@
       </p:sp>
       <p:sp>
         <p:nvSpPr>
-          <p:cNvPr id="19" name="Text 17"/>
+          <p:cNvPr id="10" name="Text 8"/>
           <p:cNvSpPr/>
           <p:nvPr/>
         </p:nvSpPr>
@@ -1663,7 +1279,7 @@
       </p:sp>
       <p:sp>
         <p:nvSpPr>
-          <p:cNvPr id="20" name="Text 18"/>
+          <p:cNvPr id="11" name="Text 9"/>
           <p:cNvSpPr/>
           <p:nvPr/>
         </p:nvSpPr>

</xml_diff>

<commit_message>
Update Model 2 deck bullets to reflect actual prototype capabilities
Co-Authored-By: Claude Opus 4.6 <noreply@anthropic.com>
</commit_message>
<xml_diff>
--- a/public/deck/iShares_Direct_Personalization_2_Slides.pptx
+++ b/public/deck/iShares_Direct_Personalization_2_Slides.pptx
@@ -2243,7 +2243,7 @@
                 <a:ea typeface="Arial" pitchFamily="34" charset="-122"/>
                 <a:cs typeface="Arial" pitchFamily="34" charset="-120"/>
               </a:rPr>
-              <a:t>AI-adaptive conversation profiles investors</a:t>
+              <a:t>12-step adaptive intake + 2 AI open-text insights</a:t>
             </a:r>
             <a:endParaRPr lang="en-US" sz="900" dirty="0"/>
           </a:p>
@@ -2296,7 +2296,7 @@
                 <a:ea typeface="Arial" pitchFamily="34" charset="-122"/>
                 <a:cs typeface="Arial" pitchFamily="34" charset="-120"/>
               </a:rPr>
-              <a:t>Matches to 15–20 pre-built model portfolios</a:t>
+              <a:t>8 risk-scored portfolios from 27 iShares ETFs</a:t>
             </a:r>
             <a:endParaRPr lang="en-US" sz="900" dirty="0"/>
           </a:p>
@@ -2349,7 +2349,7 @@
                 <a:ea typeface="Arial" pitchFamily="34" charset="-122"/>
                 <a:cs typeface="Arial" pitchFamily="34" charset="-120"/>
               </a:rPr>
-              <a:t>Full iShares + BlackRock active ETFs</a:t>
+              <a:t>Multi-factor scoring from 6+ behavioral signals</a:t>
             </a:r>
             <a:endParaRPr lang="en-US" sz="900" dirty="0"/>
           </a:p>
@@ -2402,7 +2402,7 @@
                 <a:ea typeface="Arial" pitchFamily="34" charset="-122"/>
                 <a:cs typeface="Arial" pitchFamily="34" charset="-120"/>
               </a:rPr>
-              <a:t>AI personalizes; humans curate portfolios</a:t>
+              <a:t>Theme overlays: AI, Clean, Infra, Defense</a:t>
             </a:r>
             <a:endParaRPr lang="en-US" sz="900" dirty="0"/>
           </a:p>

</xml_diff>

<commit_message>
Slide 2: center bullet points in cards, remove timeline/cost footers
Co-Authored-By: Claude Opus 4.6 <noreply@anthropic.com>
</commit_message>
<xml_diff>
--- a/public/deck/iShares_Direct_Personalization_2_Slides.pptx
+++ b/public/deck/iShares_Direct_Personalization_2_Slides.pptx
@@ -1772,7 +1772,7 @@
         </p:nvSpPr>
         <p:spPr>
           <a:xfrm>
-            <a:off x="594360" y="2633472"/>
+            <a:off x="594360" y="2779776"/>
             <a:ext cx="2313432" cy="292608"/>
           </a:xfrm>
           <a:prstGeom prst="rect">
@@ -1825,7 +1825,7 @@
         </p:nvSpPr>
         <p:spPr>
           <a:xfrm>
-            <a:off x="594360" y="2953512"/>
+            <a:off x="594360" y="3099816"/>
             <a:ext cx="2313432" cy="292608"/>
           </a:xfrm>
           <a:prstGeom prst="rect">
@@ -1878,7 +1878,7 @@
         </p:nvSpPr>
         <p:spPr>
           <a:xfrm>
-            <a:off x="594360" y="3273552"/>
+            <a:off x="594360" y="3419856"/>
             <a:ext cx="2313432" cy="292608"/>
           </a:xfrm>
           <a:prstGeom prst="rect">
@@ -1931,7 +1931,7 @@
         </p:nvSpPr>
         <p:spPr>
           <a:xfrm>
-            <a:off x="594360" y="3593592"/>
+            <a:off x="594360" y="3739896"/>
             <a:ext cx="2313432" cy="292608"/>
           </a:xfrm>
           <a:prstGeom prst="rect">
@@ -1978,102 +1978,7 @@
       </p:sp>
       <p:sp>
         <p:nvSpPr>
-          <p:cNvPr id="20" name="Text 18"/>
-          <p:cNvSpPr/>
-          <p:nvPr/>
-        </p:nvSpPr>
-        <p:spPr>
-          <a:xfrm>
-            <a:off x="594360" y="3931920"/>
-            <a:ext cx="2313432" cy="228600"/>
-          </a:xfrm>
-          <a:prstGeom prst="rect">
-            <a:avLst/>
-          </a:prstGeom>
-          <a:noFill/>
-          <a:ln/>
-        </p:spPr>
-        <p:txBody>
-          <a:bodyPr wrap="square" lIns="0" tIns="0" rIns="0" bIns="0" rtlCol="0" anchor="ctr"/>
-          <a:lstStyle/>
-          <a:p>
-            <a:pPr indent="0" marL="0">
-              <a:buNone/>
-            </a:pPr>
-            <a:r>
-              <a:rPr lang="en-US" sz="900" b="1" dirty="0">
-                <a:solidFill>
-                  <a:srgbClr val="000000"/>
-                </a:solidFill>
-                <a:latin typeface="Arial" pitchFamily="34" charset="0"/>
-                <a:ea typeface="Arial" pitchFamily="34" charset="-122"/>
-                <a:cs typeface="Arial" pitchFamily="34" charset="-120"/>
-              </a:rPr>
-              <a:t>4–6 wks</a:t>
-            </a:r>
-            <a:pPr indent="0" marL="0">
-              <a:buNone/>
-            </a:pPr>
-            <a:r>
-              <a:rPr lang="en-US" sz="900" dirty="0">
-                <a:solidFill>
-                  <a:srgbClr val="666666"/>
-                </a:solidFill>
-                <a:latin typeface="Arial" pitchFamily="34" charset="0"/>
-                <a:ea typeface="Arial" pitchFamily="34" charset="-122"/>
-                <a:cs typeface="Arial" pitchFamily="34" charset="-120"/>
-              </a:rPr>
-              <a:t>  ·  </a:t>
-            </a:r>
-            <a:pPr indent="0" marL="0">
-              <a:buNone/>
-            </a:pPr>
-            <a:r>
-              <a:rPr lang="en-US" sz="900" b="1" dirty="0">
-                <a:solidFill>
-                  <a:srgbClr val="00A854"/>
-                </a:solidFill>
-                <a:latin typeface="Arial" pitchFamily="34" charset="0"/>
-                <a:ea typeface="Arial" pitchFamily="34" charset="-122"/>
-                <a:cs typeface="Arial" pitchFamily="34" charset="-120"/>
-              </a:rPr>
-              <a:t>$</a:t>
-            </a:r>
-            <a:pPr indent="0" marL="0">
-              <a:buNone/>
-            </a:pPr>
-            <a:r>
-              <a:rPr lang="en-US" sz="900" dirty="0">
-                <a:solidFill>
-                  <a:srgbClr val="666666"/>
-                </a:solidFill>
-                <a:latin typeface="Arial" pitchFamily="34" charset="0"/>
-                <a:ea typeface="Arial" pitchFamily="34" charset="-122"/>
-                <a:cs typeface="Arial" pitchFamily="34" charset="-120"/>
-              </a:rPr>
-              <a:t>  ·  </a:t>
-            </a:r>
-            <a:pPr indent="0" marL="0">
-              <a:buNone/>
-            </a:pPr>
-            <a:r>
-              <a:rPr lang="en-US" sz="900" dirty="0">
-                <a:solidFill>
-                  <a:srgbClr val="666666"/>
-                </a:solidFill>
-                <a:latin typeface="Arial" pitchFamily="34" charset="0"/>
-                <a:ea typeface="Arial" pitchFamily="34" charset="-122"/>
-                <a:cs typeface="Arial" pitchFamily="34" charset="-120"/>
-              </a:rPr>
-              <a:t>No AI</a:t>
-            </a:r>
-            <a:endParaRPr lang="en-US" sz="900" dirty="0"/>
-          </a:p>
-        </p:txBody>
-      </p:sp>
-      <p:sp>
-        <p:nvSpPr>
-          <p:cNvPr id="21" name="Shape 19"/>
+          <p:cNvPr id="20" name="Shape 18"/>
           <p:cNvSpPr/>
           <p:nvPr/>
         </p:nvSpPr>
@@ -2100,7 +2005,7 @@
       </p:sp>
       <p:sp>
         <p:nvSpPr>
-          <p:cNvPr id="22" name="Shape 20"/>
+          <p:cNvPr id="21" name="Shape 19"/>
           <p:cNvSpPr/>
           <p:nvPr/>
         </p:nvSpPr>
@@ -2120,7 +2025,7 @@
       </p:sp>
       <p:sp>
         <p:nvSpPr>
-          <p:cNvPr id="23" name="Text 21"/>
+          <p:cNvPr id="22" name="Text 20"/>
           <p:cNvSpPr/>
           <p:nvPr/>
         </p:nvSpPr>
@@ -2159,7 +2064,7 @@
       </p:sp>
       <p:sp>
         <p:nvSpPr>
-          <p:cNvPr id="24" name="Text 22"/>
+          <p:cNvPr id="23" name="Text 21"/>
           <p:cNvSpPr/>
           <p:nvPr/>
         </p:nvSpPr>
@@ -2198,13 +2103,66 @@
       </p:sp>
       <p:sp>
         <p:nvSpPr>
+          <p:cNvPr id="24" name="Text 22"/>
+          <p:cNvSpPr/>
+          <p:nvPr/>
+        </p:nvSpPr>
+        <p:spPr>
+          <a:xfrm>
+            <a:off x="3410712" y="2779776"/>
+            <a:ext cx="2313432" cy="292608"/>
+          </a:xfrm>
+          <a:prstGeom prst="rect">
+            <a:avLst/>
+          </a:prstGeom>
+          <a:noFill/>
+          <a:ln/>
+        </p:spPr>
+        <p:txBody>
+          <a:bodyPr wrap="square" lIns="0" tIns="0" rIns="0" bIns="0" rtlCol="0" anchor="t"/>
+          <a:lstStyle/>
+          <a:p>
+            <a:pPr indent="0" marL="0">
+              <a:buNone/>
+            </a:pPr>
+            <a:r>
+              <a:rPr lang="en-US" sz="900" dirty="0">
+                <a:solidFill>
+                  <a:srgbClr val="F6693D"/>
+                </a:solidFill>
+                <a:latin typeface="Arial" pitchFamily="34" charset="0"/>
+                <a:ea typeface="Arial" pitchFamily="34" charset="-122"/>
+                <a:cs typeface="Arial" pitchFamily="34" charset="-120"/>
+              </a:rPr>
+              <a:t>•  </a:t>
+            </a:r>
+            <a:pPr indent="0" marL="0">
+              <a:buNone/>
+            </a:pPr>
+            <a:r>
+              <a:rPr lang="en-US" sz="900" dirty="0">
+                <a:solidFill>
+                  <a:srgbClr val="333333"/>
+                </a:solidFill>
+                <a:latin typeface="Arial" pitchFamily="34" charset="0"/>
+                <a:ea typeface="Arial" pitchFamily="34" charset="-122"/>
+                <a:cs typeface="Arial" pitchFamily="34" charset="-120"/>
+              </a:rPr>
+              <a:t>12-step adaptive intake + 3 AI open-text insights</a:t>
+            </a:r>
+            <a:endParaRPr lang="en-US" sz="900" dirty="0"/>
+          </a:p>
+        </p:txBody>
+      </p:sp>
+      <p:sp>
+        <p:nvSpPr>
           <p:cNvPr id="25" name="Text 23"/>
           <p:cNvSpPr/>
           <p:nvPr/>
         </p:nvSpPr>
         <p:spPr>
           <a:xfrm>
-            <a:off x="3410712" y="2633472"/>
+            <a:off x="3410712" y="3099816"/>
             <a:ext cx="2313432" cy="292608"/>
           </a:xfrm>
           <a:prstGeom prst="rect">
@@ -2243,7 +2201,7 @@
                 <a:ea typeface="Arial" pitchFamily="34" charset="-122"/>
                 <a:cs typeface="Arial" pitchFamily="34" charset="-120"/>
               </a:rPr>
-              <a:t>12-step adaptive intake + 3 AI open-text insights</a:t>
+              <a:t>8 risk-scored portfolios from 27 iShares ETFs</a:t>
             </a:r>
             <a:endParaRPr lang="en-US" sz="900" dirty="0"/>
           </a:p>
@@ -2257,7 +2215,7 @@
         </p:nvSpPr>
         <p:spPr>
           <a:xfrm>
-            <a:off x="3410712" y="2953512"/>
+            <a:off x="3410712" y="3419856"/>
             <a:ext cx="2313432" cy="292608"/>
           </a:xfrm>
           <a:prstGeom prst="rect">
@@ -2296,7 +2254,7 @@
                 <a:ea typeface="Arial" pitchFamily="34" charset="-122"/>
                 <a:cs typeface="Arial" pitchFamily="34" charset="-120"/>
               </a:rPr>
-              <a:t>8 risk-scored portfolios from 27 iShares ETFs</a:t>
+              <a:t>Multi-factor scoring from 6+ behavioral signals</a:t>
             </a:r>
             <a:endParaRPr lang="en-US" sz="900" dirty="0"/>
           </a:p>
@@ -2310,7 +2268,7 @@
         </p:nvSpPr>
         <p:spPr>
           <a:xfrm>
-            <a:off x="3410712" y="3273552"/>
+            <a:off x="3410712" y="3739896"/>
             <a:ext cx="2313432" cy="292608"/>
           </a:xfrm>
           <a:prstGeom prst="rect">
@@ -2349,7 +2307,7 @@
                 <a:ea typeface="Arial" pitchFamily="34" charset="-122"/>
                 <a:cs typeface="Arial" pitchFamily="34" charset="-120"/>
               </a:rPr>
-              <a:t>Multi-factor scoring from 6+ behavioral signals</a:t>
+              <a:t>Theme overlays: AI, Clean, Infra, Defense</a:t>
             </a:r>
             <a:endParaRPr lang="en-US" sz="900" dirty="0"/>
           </a:p>
@@ -2357,155 +2315,7 @@
       </p:sp>
       <p:sp>
         <p:nvSpPr>
-          <p:cNvPr id="28" name="Text 26"/>
-          <p:cNvSpPr/>
-          <p:nvPr/>
-        </p:nvSpPr>
-        <p:spPr>
-          <a:xfrm>
-            <a:off x="3410712" y="3593592"/>
-            <a:ext cx="2313432" cy="292608"/>
-          </a:xfrm>
-          <a:prstGeom prst="rect">
-            <a:avLst/>
-          </a:prstGeom>
-          <a:noFill/>
-          <a:ln/>
-        </p:spPr>
-        <p:txBody>
-          <a:bodyPr wrap="square" lIns="0" tIns="0" rIns="0" bIns="0" rtlCol="0" anchor="t"/>
-          <a:lstStyle/>
-          <a:p>
-            <a:pPr indent="0" marL="0">
-              <a:buNone/>
-            </a:pPr>
-            <a:r>
-              <a:rPr lang="en-US" sz="900" dirty="0">
-                <a:solidFill>
-                  <a:srgbClr val="F6693D"/>
-                </a:solidFill>
-                <a:latin typeface="Arial" pitchFamily="34" charset="0"/>
-                <a:ea typeface="Arial" pitchFamily="34" charset="-122"/>
-                <a:cs typeface="Arial" pitchFamily="34" charset="-120"/>
-              </a:rPr>
-              <a:t>•  </a:t>
-            </a:r>
-            <a:pPr indent="0" marL="0">
-              <a:buNone/>
-            </a:pPr>
-            <a:r>
-              <a:rPr lang="en-US" sz="900" dirty="0">
-                <a:solidFill>
-                  <a:srgbClr val="333333"/>
-                </a:solidFill>
-                <a:latin typeface="Arial" pitchFamily="34" charset="0"/>
-                <a:ea typeface="Arial" pitchFamily="34" charset="-122"/>
-                <a:cs typeface="Arial" pitchFamily="34" charset="-120"/>
-              </a:rPr>
-              <a:t>Theme overlays: AI, Clean, Infra, Defense</a:t>
-            </a:r>
-            <a:endParaRPr lang="en-US" sz="900" dirty="0"/>
-          </a:p>
-        </p:txBody>
-      </p:sp>
-      <p:sp>
-        <p:nvSpPr>
-          <p:cNvPr id="29" name="Text 27"/>
-          <p:cNvSpPr/>
-          <p:nvPr/>
-        </p:nvSpPr>
-        <p:spPr>
-          <a:xfrm>
-            <a:off x="3410712" y="3931920"/>
-            <a:ext cx="2313432" cy="228600"/>
-          </a:xfrm>
-          <a:prstGeom prst="rect">
-            <a:avLst/>
-          </a:prstGeom>
-          <a:noFill/>
-          <a:ln/>
-        </p:spPr>
-        <p:txBody>
-          <a:bodyPr wrap="square" lIns="0" tIns="0" rIns="0" bIns="0" rtlCol="0" anchor="ctr"/>
-          <a:lstStyle/>
-          <a:p>
-            <a:pPr indent="0" marL="0">
-              <a:buNone/>
-            </a:pPr>
-            <a:r>
-              <a:rPr lang="en-US" sz="900" b="1" dirty="0">
-                <a:solidFill>
-                  <a:srgbClr val="000000"/>
-                </a:solidFill>
-                <a:latin typeface="Arial" pitchFamily="34" charset="0"/>
-                <a:ea typeface="Arial" pitchFamily="34" charset="-122"/>
-                <a:cs typeface="Arial" pitchFamily="34" charset="-120"/>
-              </a:rPr>
-              <a:t>3–6 mos</a:t>
-            </a:r>
-            <a:pPr indent="0" marL="0">
-              <a:buNone/>
-            </a:pPr>
-            <a:r>
-              <a:rPr lang="en-US" sz="900" dirty="0">
-                <a:solidFill>
-                  <a:srgbClr val="666666"/>
-                </a:solidFill>
-                <a:latin typeface="Arial" pitchFamily="34" charset="0"/>
-                <a:ea typeface="Arial" pitchFamily="34" charset="-122"/>
-                <a:cs typeface="Arial" pitchFamily="34" charset="-120"/>
-              </a:rPr>
-              <a:t>  ·  </a:t>
-            </a:r>
-            <a:pPr indent="0" marL="0">
-              <a:buNone/>
-            </a:pPr>
-            <a:r>
-              <a:rPr lang="en-US" sz="900" b="1" dirty="0">
-                <a:solidFill>
-                  <a:srgbClr val="F6693D"/>
-                </a:solidFill>
-                <a:latin typeface="Arial" pitchFamily="34" charset="0"/>
-                <a:ea typeface="Arial" pitchFamily="34" charset="-122"/>
-                <a:cs typeface="Arial" pitchFamily="34" charset="-120"/>
-              </a:rPr>
-              <a:t>$$$</a:t>
-            </a:r>
-            <a:pPr indent="0" marL="0">
-              <a:buNone/>
-            </a:pPr>
-            <a:r>
-              <a:rPr lang="en-US" sz="900" dirty="0">
-                <a:solidFill>
-                  <a:srgbClr val="666666"/>
-                </a:solidFill>
-                <a:latin typeface="Arial" pitchFamily="34" charset="0"/>
-                <a:ea typeface="Arial" pitchFamily="34" charset="-122"/>
-                <a:cs typeface="Arial" pitchFamily="34" charset="-120"/>
-              </a:rPr>
-              <a:t>  ·  </a:t>
-            </a:r>
-            <a:pPr indent="0" marL="0">
-              <a:buNone/>
-            </a:pPr>
-            <a:r>
-              <a:rPr lang="en-US" sz="900" dirty="0">
-                <a:solidFill>
-                  <a:srgbClr val="666666"/>
-                </a:solidFill>
-                <a:latin typeface="Arial" pitchFamily="34" charset="0"/>
-                <a:ea typeface="Arial" pitchFamily="34" charset="-122"/>
-                <a:cs typeface="Arial" pitchFamily="34" charset="-120"/>
-              </a:rPr>
-              <a:t>High AI</a:t>
-            </a:r>
-            <a:endParaRPr lang="en-US" sz="900" dirty="0"/>
-          </a:p>
-        </p:txBody>
-      </p:sp>
-      <p:sp>
-        <p:nvSpPr>
-          <p:cNvPr id="30" name="Shape 28"/>
+          <p:cNvPr id="28" name="Shape 26"/>
           <p:cNvSpPr/>
           <p:nvPr/>
         </p:nvSpPr>
@@ -2532,7 +2342,7 @@
       </p:sp>
       <p:sp>
         <p:nvSpPr>
-          <p:cNvPr id="31" name="Shape 29"/>
+          <p:cNvPr id="29" name="Shape 27"/>
           <p:cNvSpPr/>
           <p:nvPr/>
         </p:nvSpPr>
@@ -2552,7 +2362,7 @@
       </p:sp>
       <p:sp>
         <p:nvSpPr>
-          <p:cNvPr id="32" name="Text 30"/>
+          <p:cNvPr id="30" name="Text 28"/>
           <p:cNvSpPr/>
           <p:nvPr/>
         </p:nvSpPr>
@@ -2591,7 +2401,7 @@
       </p:sp>
       <p:sp>
         <p:nvSpPr>
-          <p:cNvPr id="33" name="Text 31"/>
+          <p:cNvPr id="31" name="Text 29"/>
           <p:cNvSpPr/>
           <p:nvPr/>
         </p:nvSpPr>
@@ -2630,13 +2440,119 @@
       </p:sp>
       <p:sp>
         <p:nvSpPr>
+          <p:cNvPr id="32" name="Text 30"/>
+          <p:cNvSpPr/>
+          <p:nvPr/>
+        </p:nvSpPr>
+        <p:spPr>
+          <a:xfrm>
+            <a:off x="6236208" y="2779776"/>
+            <a:ext cx="2313432" cy="292608"/>
+          </a:xfrm>
+          <a:prstGeom prst="rect">
+            <a:avLst/>
+          </a:prstGeom>
+          <a:noFill/>
+          <a:ln/>
+        </p:spPr>
+        <p:txBody>
+          <a:bodyPr wrap="square" lIns="0" tIns="0" rIns="0" bIns="0" rtlCol="0" anchor="t"/>
+          <a:lstStyle/>
+          <a:p>
+            <a:pPr indent="0" marL="0">
+              <a:buNone/>
+            </a:pPr>
+            <a:r>
+              <a:rPr lang="en-US" sz="900" dirty="0">
+                <a:solidFill>
+                  <a:srgbClr val="FFB800"/>
+                </a:solidFill>
+                <a:latin typeface="Arial" pitchFamily="34" charset="0"/>
+                <a:ea typeface="Arial" pitchFamily="34" charset="-122"/>
+                <a:cs typeface="Arial" pitchFamily="34" charset="-120"/>
+              </a:rPr>
+              <a:t>•  </a:t>
+            </a:r>
+            <a:pPr indent="0" marL="0">
+              <a:buNone/>
+            </a:pPr>
+            <a:r>
+              <a:rPr lang="en-US" sz="900" dirty="0">
+                <a:solidFill>
+                  <a:srgbClr val="333333"/>
+                </a:solidFill>
+                <a:latin typeface="Arial" pitchFamily="34" charset="0"/>
+                <a:ea typeface="Arial" pitchFamily="34" charset="-122"/>
+                <a:cs typeface="Arial" pitchFamily="34" charset="-120"/>
+              </a:rPr>
+              <a:t>LLM profiles investors + constructs portfolios</a:t>
+            </a:r>
+            <a:endParaRPr lang="en-US" sz="900" dirty="0"/>
+          </a:p>
+        </p:txBody>
+      </p:sp>
+      <p:sp>
+        <p:nvSpPr>
+          <p:cNvPr id="33" name="Text 31"/>
+          <p:cNvSpPr/>
+          <p:nvPr/>
+        </p:nvSpPr>
+        <p:spPr>
+          <a:xfrm>
+            <a:off x="6236208" y="3099816"/>
+            <a:ext cx="2313432" cy="292608"/>
+          </a:xfrm>
+          <a:prstGeom prst="rect">
+            <a:avLst/>
+          </a:prstGeom>
+          <a:noFill/>
+          <a:ln/>
+        </p:spPr>
+        <p:txBody>
+          <a:bodyPr wrap="square" lIns="0" tIns="0" rIns="0" bIns="0" rtlCol="0" anchor="t"/>
+          <a:lstStyle/>
+          <a:p>
+            <a:pPr indent="0" marL="0">
+              <a:buNone/>
+            </a:pPr>
+            <a:r>
+              <a:rPr lang="en-US" sz="900" dirty="0">
+                <a:solidFill>
+                  <a:srgbClr val="FFB800"/>
+                </a:solidFill>
+                <a:latin typeface="Arial" pitchFamily="34" charset="0"/>
+                <a:ea typeface="Arial" pitchFamily="34" charset="-122"/>
+                <a:cs typeface="Arial" pitchFamily="34" charset="-120"/>
+              </a:rPr>
+              <a:t>•  </a:t>
+            </a:r>
+            <a:pPr indent="0" marL="0">
+              <a:buNone/>
+            </a:pPr>
+            <a:r>
+              <a:rPr lang="en-US" sz="900" dirty="0">
+                <a:solidFill>
+                  <a:srgbClr val="333333"/>
+                </a:solidFill>
+                <a:latin typeface="Arial" pitchFamily="34" charset="0"/>
+                <a:ea typeface="Arial" pitchFamily="34" charset="-122"/>
+                <a:cs typeface="Arial" pitchFamily="34" charset="-120"/>
+              </a:rPr>
+              <a:t>Unlimited bespoke allocations in real-time</a:t>
+            </a:r>
+            <a:endParaRPr lang="en-US" sz="900" dirty="0"/>
+          </a:p>
+        </p:txBody>
+      </p:sp>
+      <p:sp>
+        <p:nvSpPr>
           <p:cNvPr id="34" name="Text 32"/>
           <p:cNvSpPr/>
           <p:nvPr/>
         </p:nvSpPr>
         <p:spPr>
           <a:xfrm>
-            <a:off x="6236208" y="2633472"/>
+            <a:off x="6236208" y="3419856"/>
             <a:ext cx="2313432" cy="292608"/>
           </a:xfrm>
           <a:prstGeom prst="rect">
@@ -2675,7 +2591,7 @@
                 <a:ea typeface="Arial" pitchFamily="34" charset="-122"/>
                 <a:cs typeface="Arial" pitchFamily="34" charset="-120"/>
               </a:rPr>
-              <a:t>LLM profiles investors + constructs portfolios</a:t>
+              <a:t>Ongoing chatbot for investor questions</a:t>
             </a:r>
             <a:endParaRPr lang="en-US" sz="900" dirty="0"/>
           </a:p>
@@ -2689,7 +2605,7 @@
         </p:nvSpPr>
         <p:spPr>
           <a:xfrm>
-            <a:off x="6236208" y="2953512"/>
+            <a:off x="6236208" y="3739896"/>
             <a:ext cx="2313432" cy="292608"/>
           </a:xfrm>
           <a:prstGeom prst="rect">
@@ -2728,7 +2644,7 @@
                 <a:ea typeface="Arial" pitchFamily="34" charset="-122"/>
                 <a:cs typeface="Arial" pitchFamily="34" charset="-120"/>
               </a:rPr>
-              <a:t>Unlimited bespoke allocations in real-time</a:t>
+              <a:t>AI agent: alerts, rebalancing, market insights</a:t>
             </a:r>
             <a:endParaRPr lang="en-US" sz="900" dirty="0"/>
           </a:p>
@@ -2736,208 +2652,7 @@
       </p:sp>
       <p:sp>
         <p:nvSpPr>
-          <p:cNvPr id="36" name="Text 34"/>
-          <p:cNvSpPr/>
-          <p:nvPr/>
-        </p:nvSpPr>
-        <p:spPr>
-          <a:xfrm>
-            <a:off x="6236208" y="3273552"/>
-            <a:ext cx="2313432" cy="292608"/>
-          </a:xfrm>
-          <a:prstGeom prst="rect">
-            <a:avLst/>
-          </a:prstGeom>
-          <a:noFill/>
-          <a:ln/>
-        </p:spPr>
-        <p:txBody>
-          <a:bodyPr wrap="square" lIns="0" tIns="0" rIns="0" bIns="0" rtlCol="0" anchor="t"/>
-          <a:lstStyle/>
-          <a:p>
-            <a:pPr indent="0" marL="0">
-              <a:buNone/>
-            </a:pPr>
-            <a:r>
-              <a:rPr lang="en-US" sz="900" dirty="0">
-                <a:solidFill>
-                  <a:srgbClr val="FFB800"/>
-                </a:solidFill>
-                <a:latin typeface="Arial" pitchFamily="34" charset="0"/>
-                <a:ea typeface="Arial" pitchFamily="34" charset="-122"/>
-                <a:cs typeface="Arial" pitchFamily="34" charset="-120"/>
-              </a:rPr>
-              <a:t>•  </a:t>
-            </a:r>
-            <a:pPr indent="0" marL="0">
-              <a:buNone/>
-            </a:pPr>
-            <a:r>
-              <a:rPr lang="en-US" sz="900" dirty="0">
-                <a:solidFill>
-                  <a:srgbClr val="333333"/>
-                </a:solidFill>
-                <a:latin typeface="Arial" pitchFamily="34" charset="0"/>
-                <a:ea typeface="Arial" pitchFamily="34" charset="-122"/>
-                <a:cs typeface="Arial" pitchFamily="34" charset="-120"/>
-              </a:rPr>
-              <a:t>Ongoing chatbot for investor questions</a:t>
-            </a:r>
-            <a:endParaRPr lang="en-US" sz="900" dirty="0"/>
-          </a:p>
-        </p:txBody>
-      </p:sp>
-      <p:sp>
-        <p:nvSpPr>
-          <p:cNvPr id="37" name="Text 35"/>
-          <p:cNvSpPr/>
-          <p:nvPr/>
-        </p:nvSpPr>
-        <p:spPr>
-          <a:xfrm>
-            <a:off x="6236208" y="3593592"/>
-            <a:ext cx="2313432" cy="292608"/>
-          </a:xfrm>
-          <a:prstGeom prst="rect">
-            <a:avLst/>
-          </a:prstGeom>
-          <a:noFill/>
-          <a:ln/>
-        </p:spPr>
-        <p:txBody>
-          <a:bodyPr wrap="square" lIns="0" tIns="0" rIns="0" bIns="0" rtlCol="0" anchor="t"/>
-          <a:lstStyle/>
-          <a:p>
-            <a:pPr indent="0" marL="0">
-              <a:buNone/>
-            </a:pPr>
-            <a:r>
-              <a:rPr lang="en-US" sz="900" dirty="0">
-                <a:solidFill>
-                  <a:srgbClr val="FFB800"/>
-                </a:solidFill>
-                <a:latin typeface="Arial" pitchFamily="34" charset="0"/>
-                <a:ea typeface="Arial" pitchFamily="34" charset="-122"/>
-                <a:cs typeface="Arial" pitchFamily="34" charset="-120"/>
-              </a:rPr>
-              <a:t>•  </a:t>
-            </a:r>
-            <a:pPr indent="0" marL="0">
-              <a:buNone/>
-            </a:pPr>
-            <a:r>
-              <a:rPr lang="en-US" sz="900" dirty="0">
-                <a:solidFill>
-                  <a:srgbClr val="333333"/>
-                </a:solidFill>
-                <a:latin typeface="Arial" pitchFamily="34" charset="0"/>
-                <a:ea typeface="Arial" pitchFamily="34" charset="-122"/>
-                <a:cs typeface="Arial" pitchFamily="34" charset="-120"/>
-              </a:rPr>
-              <a:t>AI agent: alerts, rebalancing, market insights</a:t>
-            </a:r>
-            <a:endParaRPr lang="en-US" sz="900" dirty="0"/>
-          </a:p>
-        </p:txBody>
-      </p:sp>
-      <p:sp>
-        <p:nvSpPr>
-          <p:cNvPr id="38" name="Text 36"/>
-          <p:cNvSpPr/>
-          <p:nvPr/>
-        </p:nvSpPr>
-        <p:spPr>
-          <a:xfrm>
-            <a:off x="6236208" y="3931920"/>
-            <a:ext cx="2313432" cy="228600"/>
-          </a:xfrm>
-          <a:prstGeom prst="rect">
-            <a:avLst/>
-          </a:prstGeom>
-          <a:noFill/>
-          <a:ln/>
-        </p:spPr>
-        <p:txBody>
-          <a:bodyPr wrap="square" lIns="0" tIns="0" rIns="0" bIns="0" rtlCol="0" anchor="ctr"/>
-          <a:lstStyle/>
-          <a:p>
-            <a:pPr indent="0" marL="0">
-              <a:buNone/>
-            </a:pPr>
-            <a:r>
-              <a:rPr lang="en-US" sz="900" b="1" dirty="0">
-                <a:solidFill>
-                  <a:srgbClr val="000000"/>
-                </a:solidFill>
-                <a:latin typeface="Arial" pitchFamily="34" charset="0"/>
-                <a:ea typeface="Arial" pitchFamily="34" charset="-122"/>
-                <a:cs typeface="Arial" pitchFamily="34" charset="-120"/>
-              </a:rPr>
-              <a:t>6–12 mos</a:t>
-            </a:r>
-            <a:pPr indent="0" marL="0">
-              <a:buNone/>
-            </a:pPr>
-            <a:r>
-              <a:rPr lang="en-US" sz="900" dirty="0">
-                <a:solidFill>
-                  <a:srgbClr val="666666"/>
-                </a:solidFill>
-                <a:latin typeface="Arial" pitchFamily="34" charset="0"/>
-                <a:ea typeface="Arial" pitchFamily="34" charset="-122"/>
-                <a:cs typeface="Arial" pitchFamily="34" charset="-120"/>
-              </a:rPr>
-              <a:t>  ·  </a:t>
-            </a:r>
-            <a:pPr indent="0" marL="0">
-              <a:buNone/>
-            </a:pPr>
-            <a:r>
-              <a:rPr lang="en-US" sz="900" b="1" dirty="0">
-                <a:solidFill>
-                  <a:srgbClr val="FFB800"/>
-                </a:solidFill>
-                <a:latin typeface="Arial" pitchFamily="34" charset="0"/>
-                <a:ea typeface="Arial" pitchFamily="34" charset="-122"/>
-                <a:cs typeface="Arial" pitchFamily="34" charset="-120"/>
-              </a:rPr>
-              <a:t>$$$$</a:t>
-            </a:r>
-            <a:pPr indent="0" marL="0">
-              <a:buNone/>
-            </a:pPr>
-            <a:r>
-              <a:rPr lang="en-US" sz="900" dirty="0">
-                <a:solidFill>
-                  <a:srgbClr val="666666"/>
-                </a:solidFill>
-                <a:latin typeface="Arial" pitchFamily="34" charset="0"/>
-                <a:ea typeface="Arial" pitchFamily="34" charset="-122"/>
-                <a:cs typeface="Arial" pitchFamily="34" charset="-120"/>
-              </a:rPr>
-              <a:t>  ·  </a:t>
-            </a:r>
-            <a:pPr indent="0" marL="0">
-              <a:buNone/>
-            </a:pPr>
-            <a:r>
-              <a:rPr lang="en-US" sz="900" dirty="0">
-                <a:solidFill>
-                  <a:srgbClr val="666666"/>
-                </a:solidFill>
-                <a:latin typeface="Arial" pitchFamily="34" charset="0"/>
-                <a:ea typeface="Arial" pitchFamily="34" charset="-122"/>
-                <a:cs typeface="Arial" pitchFamily="34" charset="-120"/>
-              </a:rPr>
-              <a:t>Very High AI</a:t>
-            </a:r>
-            <a:endParaRPr lang="en-US" sz="900" dirty="0"/>
-          </a:p>
-        </p:txBody>
-      </p:sp>
-      <p:sp>
-        <p:nvSpPr>
-          <p:cNvPr id="39" name="Shape 37"/>
+          <p:cNvPr id="36" name="Shape 34"/>
           <p:cNvSpPr/>
           <p:nvPr/>
         </p:nvSpPr>
@@ -2957,7 +2672,7 @@
       </p:sp>
       <p:sp>
         <p:nvSpPr>
-          <p:cNvPr id="40" name="Text 38"/>
+          <p:cNvPr id="37" name="Text 35"/>
           <p:cNvSpPr/>
           <p:nvPr/>
         </p:nvSpPr>
@@ -2996,7 +2711,7 @@
       </p:sp>
       <p:sp>
         <p:nvSpPr>
-          <p:cNvPr id="41" name="Text 39"/>
+          <p:cNvPr id="38" name="Text 36"/>
           <p:cNvSpPr/>
           <p:nvPr/>
         </p:nvSpPr>

</xml_diff>

<commit_message>
Fix Model 1 bullet alignment, regenerate slide JPGs for deck page
Co-Authored-By: Claude Opus 4.6 <noreply@anthropic.com>
</commit_message>
<xml_diff>
--- a/public/deck/iShares_Direct_Personalization_2_Slides.pptx
+++ b/public/deck/iShares_Direct_Personalization_2_Slides.pptx
@@ -1772,7 +1772,7 @@
         </p:nvSpPr>
         <p:spPr>
           <a:xfrm>
-            <a:off x="594360" y="2779776"/>
+            <a:off x="594360" y="2926080"/>
             <a:ext cx="2313432" cy="292608"/>
           </a:xfrm>
           <a:prstGeom prst="rect">
@@ -1825,7 +1825,7 @@
         </p:nvSpPr>
         <p:spPr>
           <a:xfrm>
-            <a:off x="594360" y="3099816"/>
+            <a:off x="594360" y="3246120"/>
             <a:ext cx="2313432" cy="292608"/>
           </a:xfrm>
           <a:prstGeom prst="rect">
@@ -1878,7 +1878,7 @@
         </p:nvSpPr>
         <p:spPr>
           <a:xfrm>
-            <a:off x="594360" y="3419856"/>
+            <a:off x="594360" y="3566160"/>
             <a:ext cx="2313432" cy="292608"/>
           </a:xfrm>
           <a:prstGeom prst="rect">
@@ -1931,7 +1931,7 @@
         </p:nvSpPr>
         <p:spPr>
           <a:xfrm>
-            <a:off x="594360" y="3739896"/>
+            <a:off x="594360" y="3886200"/>
             <a:ext cx="2313432" cy="292608"/>
           </a:xfrm>
           <a:prstGeom prst="rect">

</xml_diff>

<commit_message>
Remove bullet points from slide 2 model cards
Co-Authored-By: Claude Opus 4.6 <noreply@anthropic.com>
</commit_message>
<xml_diff>
--- a/public/deck/iShares_Direct_Personalization_2_Slides.pptx
+++ b/public/deck/iShares_Direct_Personalization_2_Slides.pptx
@@ -1791,14 +1791,39 @@
             <a:r>
               <a:rPr lang="en-US" sz="900" dirty="0">
                 <a:solidFill>
-                  <a:srgbClr val="00A854"/>
+                  <a:srgbClr val="333333"/>
                 </a:solidFill>
                 <a:latin typeface="Arial" pitchFamily="34" charset="0"/>
                 <a:ea typeface="Arial" pitchFamily="34" charset="-122"/>
                 <a:cs typeface="Arial" pitchFamily="34" charset="-120"/>
               </a:rPr>
-              <a:t>•  </a:t>
-            </a:r>
+              <a:t>Static questionnaire → ~5 allocation ETFs</a:t>
+            </a:r>
+            <a:endParaRPr lang="en-US" sz="900" dirty="0"/>
+          </a:p>
+        </p:txBody>
+      </p:sp>
+      <p:sp>
+        <p:nvSpPr>
+          <p:cNvPr id="17" name="Text 15"/>
+          <p:cNvSpPr/>
+          <p:nvPr/>
+        </p:nvSpPr>
+        <p:spPr>
+          <a:xfrm>
+            <a:off x="594360" y="3246120"/>
+            <a:ext cx="2313432" cy="292608"/>
+          </a:xfrm>
+          <a:prstGeom prst="rect">
+            <a:avLst/>
+          </a:prstGeom>
+          <a:noFill/>
+          <a:ln/>
+        </p:spPr>
+        <p:txBody>
+          <a:bodyPr wrap="square" lIns="0" tIns="0" rIns="0" bIns="0" rtlCol="0" anchor="t"/>
+          <a:lstStyle/>
+          <a:p>
             <a:pPr indent="0" marL="0">
               <a:buNone/>
             </a:pPr>
@@ -1811,7 +1836,7 @@
                 <a:ea typeface="Arial" pitchFamily="34" charset="-122"/>
                 <a:cs typeface="Arial" pitchFamily="34" charset="-120"/>
               </a:rPr>
-              <a:t>Static questionnaire → ~5 allocation ETFs</a:t>
+              <a:t>Single-ticker portfolios (AOA, AOR, AOM, AOK)</a:t>
             </a:r>
             <a:endParaRPr lang="en-US" sz="900" dirty="0"/>
           </a:p>
@@ -1819,13 +1844,13 @@
       </p:sp>
       <p:sp>
         <p:nvSpPr>
-          <p:cNvPr id="17" name="Text 15"/>
-          <p:cNvSpPr/>
-          <p:nvPr/>
-        </p:nvSpPr>
-        <p:spPr>
-          <a:xfrm>
-            <a:off x="594360" y="3246120"/>
+          <p:cNvPr id="18" name="Text 16"/>
+          <p:cNvSpPr/>
+          <p:nvPr/>
+        </p:nvSpPr>
+        <p:spPr>
+          <a:xfrm>
+            <a:off x="594360" y="3566160"/>
             <a:ext cx="2313432" cy="292608"/>
           </a:xfrm>
           <a:prstGeom prst="rect">
@@ -1844,79 +1869,12 @@
             <a:r>
               <a:rPr lang="en-US" sz="900" dirty="0">
                 <a:solidFill>
-                  <a:srgbClr val="00A854"/>
+                  <a:srgbClr val="333333"/>
                 </a:solidFill>
                 <a:latin typeface="Arial" pitchFamily="34" charset="0"/>
                 <a:ea typeface="Arial" pitchFamily="34" charset="-122"/>
                 <a:cs typeface="Arial" pitchFamily="34" charset="-120"/>
               </a:rPr>
-              <a:t>•  </a:t>
-            </a:r>
-            <a:pPr indent="0" marL="0">
-              <a:buNone/>
-            </a:pPr>
-            <a:r>
-              <a:rPr lang="en-US" sz="900" dirty="0">
-                <a:solidFill>
-                  <a:srgbClr val="333333"/>
-                </a:solidFill>
-                <a:latin typeface="Arial" pitchFamily="34" charset="0"/>
-                <a:ea typeface="Arial" pitchFamily="34" charset="-122"/>
-                <a:cs typeface="Arial" pitchFamily="34" charset="-120"/>
-              </a:rPr>
-              <a:t>Single-ticker portfolios (AOA, AOR, AOM, AOK)</a:t>
-            </a:r>
-            <a:endParaRPr lang="en-US" sz="900" dirty="0"/>
-          </a:p>
-        </p:txBody>
-      </p:sp>
-      <p:sp>
-        <p:nvSpPr>
-          <p:cNvPr id="18" name="Text 16"/>
-          <p:cNvSpPr/>
-          <p:nvPr/>
-        </p:nvSpPr>
-        <p:spPr>
-          <a:xfrm>
-            <a:off x="594360" y="3566160"/>
-            <a:ext cx="2313432" cy="292608"/>
-          </a:xfrm>
-          <a:prstGeom prst="rect">
-            <a:avLst/>
-          </a:prstGeom>
-          <a:noFill/>
-          <a:ln/>
-        </p:spPr>
-        <p:txBody>
-          <a:bodyPr wrap="square" lIns="0" tIns="0" rIns="0" bIns="0" rtlCol="0" anchor="t"/>
-          <a:lstStyle/>
-          <a:p>
-            <a:pPr indent="0" marL="0">
-              <a:buNone/>
-            </a:pPr>
-            <a:r>
-              <a:rPr lang="en-US" sz="900" dirty="0">
-                <a:solidFill>
-                  <a:srgbClr val="00A854"/>
-                </a:solidFill>
-                <a:latin typeface="Arial" pitchFamily="34" charset="0"/>
-                <a:ea typeface="Arial" pitchFamily="34" charset="-122"/>
-                <a:cs typeface="Arial" pitchFamily="34" charset="-120"/>
-              </a:rPr>
-              <a:t>•  </a:t>
-            </a:r>
-            <a:pPr indent="0" marL="0">
-              <a:buNone/>
-            </a:pPr>
-            <a:r>
-              <a:rPr lang="en-US" sz="900" dirty="0">
-                <a:solidFill>
-                  <a:srgbClr val="333333"/>
-                </a:solidFill>
-                <a:latin typeface="Arial" pitchFamily="34" charset="0"/>
-                <a:ea typeface="Arial" pitchFamily="34" charset="-122"/>
-                <a:cs typeface="Arial" pitchFamily="34" charset="-120"/>
-              </a:rPr>
               <a:t>No rebalancing required</a:t>
             </a:r>
             <a:endParaRPr lang="en-US" sz="900" dirty="0"/>
@@ -1944,20 +1902,6 @@
           <a:bodyPr wrap="square" lIns="0" tIns="0" rIns="0" bIns="0" rtlCol="0" anchor="t"/>
           <a:lstStyle/>
           <a:p>
-            <a:pPr indent="0" marL="0">
-              <a:buNone/>
-            </a:pPr>
-            <a:r>
-              <a:rPr lang="en-US" sz="900" dirty="0">
-                <a:solidFill>
-                  <a:srgbClr val="00A854"/>
-                </a:solidFill>
-                <a:latin typeface="Arial" pitchFamily="34" charset="0"/>
-                <a:ea typeface="Arial" pitchFamily="34" charset="-122"/>
-                <a:cs typeface="Arial" pitchFamily="34" charset="-120"/>
-              </a:rPr>
-              <a:t>•  </a:t>
-            </a:r>
             <a:pPr indent="0" marL="0">
               <a:buNone/>
             </a:pPr>
@@ -2128,14 +2072,39 @@
             <a:r>
               <a:rPr lang="en-US" sz="900" dirty="0">
                 <a:solidFill>
-                  <a:srgbClr val="F6693D"/>
+                  <a:srgbClr val="333333"/>
                 </a:solidFill>
                 <a:latin typeface="Arial" pitchFamily="34" charset="0"/>
                 <a:ea typeface="Arial" pitchFamily="34" charset="-122"/>
                 <a:cs typeface="Arial" pitchFamily="34" charset="-120"/>
               </a:rPr>
-              <a:t>•  </a:t>
-            </a:r>
+              <a:t>12-step adaptive intake + 3 AI open-text insights</a:t>
+            </a:r>
+            <a:endParaRPr lang="en-US" sz="900" dirty="0"/>
+          </a:p>
+        </p:txBody>
+      </p:sp>
+      <p:sp>
+        <p:nvSpPr>
+          <p:cNvPr id="25" name="Text 23"/>
+          <p:cNvSpPr/>
+          <p:nvPr/>
+        </p:nvSpPr>
+        <p:spPr>
+          <a:xfrm>
+            <a:off x="3410712" y="3099816"/>
+            <a:ext cx="2313432" cy="292608"/>
+          </a:xfrm>
+          <a:prstGeom prst="rect">
+            <a:avLst/>
+          </a:prstGeom>
+          <a:noFill/>
+          <a:ln/>
+        </p:spPr>
+        <p:txBody>
+          <a:bodyPr wrap="square" lIns="0" tIns="0" rIns="0" bIns="0" rtlCol="0" anchor="t"/>
+          <a:lstStyle/>
+          <a:p>
             <a:pPr indent="0" marL="0">
               <a:buNone/>
             </a:pPr>
@@ -2148,7 +2117,7 @@
                 <a:ea typeface="Arial" pitchFamily="34" charset="-122"/>
                 <a:cs typeface="Arial" pitchFamily="34" charset="-120"/>
               </a:rPr>
-              <a:t>12-step adaptive intake + 3 AI open-text insights</a:t>
+              <a:t>8 risk-scored portfolios from 27 iShares ETFs</a:t>
             </a:r>
             <a:endParaRPr lang="en-US" sz="900" dirty="0"/>
           </a:p>
@@ -2156,13 +2125,13 @@
       </p:sp>
       <p:sp>
         <p:nvSpPr>
-          <p:cNvPr id="25" name="Text 23"/>
-          <p:cNvSpPr/>
-          <p:nvPr/>
-        </p:nvSpPr>
-        <p:spPr>
-          <a:xfrm>
-            <a:off x="3410712" y="3099816"/>
+          <p:cNvPr id="26" name="Text 24"/>
+          <p:cNvSpPr/>
+          <p:nvPr/>
+        </p:nvSpPr>
+        <p:spPr>
+          <a:xfrm>
+            <a:off x="3410712" y="3419856"/>
             <a:ext cx="2313432" cy="292608"/>
           </a:xfrm>
           <a:prstGeom prst="rect">
@@ -2181,79 +2150,12 @@
             <a:r>
               <a:rPr lang="en-US" sz="900" dirty="0">
                 <a:solidFill>
-                  <a:srgbClr val="F6693D"/>
+                  <a:srgbClr val="333333"/>
                 </a:solidFill>
                 <a:latin typeface="Arial" pitchFamily="34" charset="0"/>
                 <a:ea typeface="Arial" pitchFamily="34" charset="-122"/>
                 <a:cs typeface="Arial" pitchFamily="34" charset="-120"/>
               </a:rPr>
-              <a:t>•  </a:t>
-            </a:r>
-            <a:pPr indent="0" marL="0">
-              <a:buNone/>
-            </a:pPr>
-            <a:r>
-              <a:rPr lang="en-US" sz="900" dirty="0">
-                <a:solidFill>
-                  <a:srgbClr val="333333"/>
-                </a:solidFill>
-                <a:latin typeface="Arial" pitchFamily="34" charset="0"/>
-                <a:ea typeface="Arial" pitchFamily="34" charset="-122"/>
-                <a:cs typeface="Arial" pitchFamily="34" charset="-120"/>
-              </a:rPr>
-              <a:t>8 risk-scored portfolios from 27 iShares ETFs</a:t>
-            </a:r>
-            <a:endParaRPr lang="en-US" sz="900" dirty="0"/>
-          </a:p>
-        </p:txBody>
-      </p:sp>
-      <p:sp>
-        <p:nvSpPr>
-          <p:cNvPr id="26" name="Text 24"/>
-          <p:cNvSpPr/>
-          <p:nvPr/>
-        </p:nvSpPr>
-        <p:spPr>
-          <a:xfrm>
-            <a:off x="3410712" y="3419856"/>
-            <a:ext cx="2313432" cy="292608"/>
-          </a:xfrm>
-          <a:prstGeom prst="rect">
-            <a:avLst/>
-          </a:prstGeom>
-          <a:noFill/>
-          <a:ln/>
-        </p:spPr>
-        <p:txBody>
-          <a:bodyPr wrap="square" lIns="0" tIns="0" rIns="0" bIns="0" rtlCol="0" anchor="t"/>
-          <a:lstStyle/>
-          <a:p>
-            <a:pPr indent="0" marL="0">
-              <a:buNone/>
-            </a:pPr>
-            <a:r>
-              <a:rPr lang="en-US" sz="900" dirty="0">
-                <a:solidFill>
-                  <a:srgbClr val="F6693D"/>
-                </a:solidFill>
-                <a:latin typeface="Arial" pitchFamily="34" charset="0"/>
-                <a:ea typeface="Arial" pitchFamily="34" charset="-122"/>
-                <a:cs typeface="Arial" pitchFamily="34" charset="-120"/>
-              </a:rPr>
-              <a:t>•  </a:t>
-            </a:r>
-            <a:pPr indent="0" marL="0">
-              <a:buNone/>
-            </a:pPr>
-            <a:r>
-              <a:rPr lang="en-US" sz="900" dirty="0">
-                <a:solidFill>
-                  <a:srgbClr val="333333"/>
-                </a:solidFill>
-                <a:latin typeface="Arial" pitchFamily="34" charset="0"/>
-                <a:ea typeface="Arial" pitchFamily="34" charset="-122"/>
-                <a:cs typeface="Arial" pitchFamily="34" charset="-120"/>
-              </a:rPr>
               <a:t>Multi-factor scoring from 6+ behavioral signals</a:t>
             </a:r>
             <a:endParaRPr lang="en-US" sz="900" dirty="0"/>
@@ -2281,20 +2183,6 @@
           <a:bodyPr wrap="square" lIns="0" tIns="0" rIns="0" bIns="0" rtlCol="0" anchor="t"/>
           <a:lstStyle/>
           <a:p>
-            <a:pPr indent="0" marL="0">
-              <a:buNone/>
-            </a:pPr>
-            <a:r>
-              <a:rPr lang="en-US" sz="900" dirty="0">
-                <a:solidFill>
-                  <a:srgbClr val="F6693D"/>
-                </a:solidFill>
-                <a:latin typeface="Arial" pitchFamily="34" charset="0"/>
-                <a:ea typeface="Arial" pitchFamily="34" charset="-122"/>
-                <a:cs typeface="Arial" pitchFamily="34" charset="-120"/>
-              </a:rPr>
-              <a:t>•  </a:t>
-            </a:r>
             <a:pPr indent="0" marL="0">
               <a:buNone/>
             </a:pPr>
@@ -2465,14 +2353,39 @@
             <a:r>
               <a:rPr lang="en-US" sz="900" dirty="0">
                 <a:solidFill>
-                  <a:srgbClr val="FFB800"/>
+                  <a:srgbClr val="333333"/>
                 </a:solidFill>
                 <a:latin typeface="Arial" pitchFamily="34" charset="0"/>
                 <a:ea typeface="Arial" pitchFamily="34" charset="-122"/>
                 <a:cs typeface="Arial" pitchFamily="34" charset="-120"/>
               </a:rPr>
-              <a:t>•  </a:t>
-            </a:r>
+              <a:t>LLM profiles investors + constructs portfolios</a:t>
+            </a:r>
+            <a:endParaRPr lang="en-US" sz="900" dirty="0"/>
+          </a:p>
+        </p:txBody>
+      </p:sp>
+      <p:sp>
+        <p:nvSpPr>
+          <p:cNvPr id="33" name="Text 31"/>
+          <p:cNvSpPr/>
+          <p:nvPr/>
+        </p:nvSpPr>
+        <p:spPr>
+          <a:xfrm>
+            <a:off x="6236208" y="3099816"/>
+            <a:ext cx="2313432" cy="292608"/>
+          </a:xfrm>
+          <a:prstGeom prst="rect">
+            <a:avLst/>
+          </a:prstGeom>
+          <a:noFill/>
+          <a:ln/>
+        </p:spPr>
+        <p:txBody>
+          <a:bodyPr wrap="square" lIns="0" tIns="0" rIns="0" bIns="0" rtlCol="0" anchor="t"/>
+          <a:lstStyle/>
+          <a:p>
             <a:pPr indent="0" marL="0">
               <a:buNone/>
             </a:pPr>
@@ -2485,7 +2398,7 @@
                 <a:ea typeface="Arial" pitchFamily="34" charset="-122"/>
                 <a:cs typeface="Arial" pitchFamily="34" charset="-120"/>
               </a:rPr>
-              <a:t>LLM profiles investors + constructs portfolios</a:t>
+              <a:t>Unlimited bespoke allocations in real-time</a:t>
             </a:r>
             <a:endParaRPr lang="en-US" sz="900" dirty="0"/>
           </a:p>
@@ -2493,13 +2406,13 @@
       </p:sp>
       <p:sp>
         <p:nvSpPr>
-          <p:cNvPr id="33" name="Text 31"/>
-          <p:cNvSpPr/>
-          <p:nvPr/>
-        </p:nvSpPr>
-        <p:spPr>
-          <a:xfrm>
-            <a:off x="6236208" y="3099816"/>
+          <p:cNvPr id="34" name="Text 32"/>
+          <p:cNvSpPr/>
+          <p:nvPr/>
+        </p:nvSpPr>
+        <p:spPr>
+          <a:xfrm>
+            <a:off x="6236208" y="3419856"/>
             <a:ext cx="2313432" cy="292608"/>
           </a:xfrm>
           <a:prstGeom prst="rect">
@@ -2518,79 +2431,12 @@
             <a:r>
               <a:rPr lang="en-US" sz="900" dirty="0">
                 <a:solidFill>
-                  <a:srgbClr val="FFB800"/>
+                  <a:srgbClr val="333333"/>
                 </a:solidFill>
                 <a:latin typeface="Arial" pitchFamily="34" charset="0"/>
                 <a:ea typeface="Arial" pitchFamily="34" charset="-122"/>
                 <a:cs typeface="Arial" pitchFamily="34" charset="-120"/>
               </a:rPr>
-              <a:t>•  </a:t>
-            </a:r>
-            <a:pPr indent="0" marL="0">
-              <a:buNone/>
-            </a:pPr>
-            <a:r>
-              <a:rPr lang="en-US" sz="900" dirty="0">
-                <a:solidFill>
-                  <a:srgbClr val="333333"/>
-                </a:solidFill>
-                <a:latin typeface="Arial" pitchFamily="34" charset="0"/>
-                <a:ea typeface="Arial" pitchFamily="34" charset="-122"/>
-                <a:cs typeface="Arial" pitchFamily="34" charset="-120"/>
-              </a:rPr>
-              <a:t>Unlimited bespoke allocations in real-time</a:t>
-            </a:r>
-            <a:endParaRPr lang="en-US" sz="900" dirty="0"/>
-          </a:p>
-        </p:txBody>
-      </p:sp>
-      <p:sp>
-        <p:nvSpPr>
-          <p:cNvPr id="34" name="Text 32"/>
-          <p:cNvSpPr/>
-          <p:nvPr/>
-        </p:nvSpPr>
-        <p:spPr>
-          <a:xfrm>
-            <a:off x="6236208" y="3419856"/>
-            <a:ext cx="2313432" cy="292608"/>
-          </a:xfrm>
-          <a:prstGeom prst="rect">
-            <a:avLst/>
-          </a:prstGeom>
-          <a:noFill/>
-          <a:ln/>
-        </p:spPr>
-        <p:txBody>
-          <a:bodyPr wrap="square" lIns="0" tIns="0" rIns="0" bIns="0" rtlCol="0" anchor="t"/>
-          <a:lstStyle/>
-          <a:p>
-            <a:pPr indent="0" marL="0">
-              <a:buNone/>
-            </a:pPr>
-            <a:r>
-              <a:rPr lang="en-US" sz="900" dirty="0">
-                <a:solidFill>
-                  <a:srgbClr val="FFB800"/>
-                </a:solidFill>
-                <a:latin typeface="Arial" pitchFamily="34" charset="0"/>
-                <a:ea typeface="Arial" pitchFamily="34" charset="-122"/>
-                <a:cs typeface="Arial" pitchFamily="34" charset="-120"/>
-              </a:rPr>
-              <a:t>•  </a:t>
-            </a:r>
-            <a:pPr indent="0" marL="0">
-              <a:buNone/>
-            </a:pPr>
-            <a:r>
-              <a:rPr lang="en-US" sz="900" dirty="0">
-                <a:solidFill>
-                  <a:srgbClr val="333333"/>
-                </a:solidFill>
-                <a:latin typeface="Arial" pitchFamily="34" charset="0"/>
-                <a:ea typeface="Arial" pitchFamily="34" charset="-122"/>
-                <a:cs typeface="Arial" pitchFamily="34" charset="-120"/>
-              </a:rPr>
               <a:t>Ongoing chatbot for investor questions</a:t>
             </a:r>
             <a:endParaRPr lang="en-US" sz="900" dirty="0"/>
@@ -2618,20 +2464,6 @@
           <a:bodyPr wrap="square" lIns="0" tIns="0" rIns="0" bIns="0" rtlCol="0" anchor="t"/>
           <a:lstStyle/>
           <a:p>
-            <a:pPr indent="0" marL="0">
-              <a:buNone/>
-            </a:pPr>
-            <a:r>
-              <a:rPr lang="en-US" sz="900" dirty="0">
-                <a:solidFill>
-                  <a:srgbClr val="FFB800"/>
-                </a:solidFill>
-                <a:latin typeface="Arial" pitchFamily="34" charset="0"/>
-                <a:ea typeface="Arial" pitchFamily="34" charset="-122"/>
-                <a:cs typeface="Arial" pitchFamily="34" charset="-120"/>
-              </a:rPr>
-              <a:t>•  </a:t>
-            </a:r>
             <a:pPr indent="0" marL="0">
               <a:buNone/>
             </a:pPr>

</xml_diff>

<commit_message>
Remove progression dots and line from slide 2
Co-Authored-By: Claude Opus 4.6 <noreply@anthropic.com>
</commit_message>
<xml_diff>
--- a/public/deck/iShares_Direct_Personalization_2_Slides.pptx
+++ b/public/deck/iShares_Direct_Personalization_2_Slides.pptx
@@ -1441,90 +1441,7 @@
       </p:sp>
       <p:sp>
         <p:nvSpPr>
-          <p:cNvPr id="5" name="Shape 3"/>
-          <p:cNvSpPr/>
-          <p:nvPr/>
-        </p:nvSpPr>
-        <p:spPr>
-          <a:xfrm>
-            <a:off x="731520" y="1444752"/>
-            <a:ext cx="7680960" cy="0"/>
-          </a:xfrm>
-          <a:prstGeom prst="line">
-            <a:avLst/>
-          </a:prstGeom>
-          <a:noFill/>
-          <a:ln w="25400">
-            <a:solidFill>
-              <a:srgbClr val="E5E5E5"/>
-            </a:solidFill>
-            <a:prstDash val="solid"/>
-          </a:ln>
-        </p:spPr>
-      </p:sp>
-      <p:sp>
-        <p:nvSpPr>
-          <p:cNvPr id="6" name="Shape 4"/>
-          <p:cNvSpPr/>
-          <p:nvPr/>
-        </p:nvSpPr>
-        <p:spPr>
-          <a:xfrm>
-            <a:off x="1261872" y="1335024"/>
-            <a:ext cx="219456" cy="219456"/>
-          </a:xfrm>
-          <a:prstGeom prst="ellipse">
-            <a:avLst/>
-          </a:prstGeom>
-          <a:solidFill>
-            <a:srgbClr val="00A854"/>
-          </a:solidFill>
-          <a:ln/>
-        </p:spPr>
-      </p:sp>
-      <p:sp>
-        <p:nvSpPr>
-          <p:cNvPr id="7" name="Shape 5"/>
-          <p:cNvSpPr/>
-          <p:nvPr/>
-        </p:nvSpPr>
-        <p:spPr>
-          <a:xfrm>
-            <a:off x="4325112" y="1335024"/>
-            <a:ext cx="219456" cy="219456"/>
-          </a:xfrm>
-          <a:prstGeom prst="ellipse">
-            <a:avLst/>
-          </a:prstGeom>
-          <a:solidFill>
-            <a:srgbClr val="F6693D"/>
-          </a:solidFill>
-          <a:ln/>
-        </p:spPr>
-      </p:sp>
-      <p:sp>
-        <p:nvSpPr>
-          <p:cNvPr id="8" name="Shape 6"/>
-          <p:cNvSpPr/>
-          <p:nvPr/>
-        </p:nvSpPr>
-        <p:spPr>
-          <a:xfrm>
-            <a:off x="7388352" y="1335024"/>
-            <a:ext cx="219456" cy="219456"/>
-          </a:xfrm>
-          <a:prstGeom prst="ellipse">
-            <a:avLst/>
-          </a:prstGeom>
-          <a:solidFill>
-            <a:srgbClr val="FFB800"/>
-          </a:solidFill>
-          <a:ln/>
-        </p:spPr>
-      </p:sp>
-      <p:sp>
-        <p:nvSpPr>
-          <p:cNvPr id="9" name="Text 7"/>
+          <p:cNvPr id="5" name="Text 3"/>
           <p:cNvSpPr/>
           <p:nvPr/>
         </p:nvSpPr>
@@ -1563,7 +1480,7 @@
       </p:sp>
       <p:sp>
         <p:nvSpPr>
-          <p:cNvPr id="10" name="Text 8"/>
+          <p:cNvPr id="6" name="Text 4"/>
           <p:cNvSpPr/>
           <p:nvPr/>
         </p:nvSpPr>
@@ -1602,7 +1519,7 @@
       </p:sp>
       <p:sp>
         <p:nvSpPr>
-          <p:cNvPr id="11" name="Text 9"/>
+          <p:cNvPr id="7" name="Text 5"/>
           <p:cNvSpPr/>
           <p:nvPr/>
         </p:nvSpPr>
@@ -1641,7 +1558,7 @@
       </p:sp>
       <p:sp>
         <p:nvSpPr>
-          <p:cNvPr id="12" name="Shape 10"/>
+          <p:cNvPr id="8" name="Shape 6"/>
           <p:cNvSpPr/>
           <p:nvPr/>
         </p:nvSpPr>
@@ -1668,7 +1585,7 @@
       </p:sp>
       <p:sp>
         <p:nvSpPr>
-          <p:cNvPr id="13" name="Shape 11"/>
+          <p:cNvPr id="9" name="Shape 7"/>
           <p:cNvSpPr/>
           <p:nvPr/>
         </p:nvSpPr>
@@ -1688,7 +1605,7 @@
       </p:sp>
       <p:sp>
         <p:nvSpPr>
-          <p:cNvPr id="14" name="Text 12"/>
+          <p:cNvPr id="10" name="Text 8"/>
           <p:cNvSpPr/>
           <p:nvPr/>
         </p:nvSpPr>
@@ -1727,7 +1644,7 @@
       </p:sp>
       <p:sp>
         <p:nvSpPr>
-          <p:cNvPr id="15" name="Text 13"/>
+          <p:cNvPr id="11" name="Text 9"/>
           <p:cNvSpPr/>
           <p:nvPr/>
         </p:nvSpPr>
@@ -1766,7 +1683,7 @@
       </p:sp>
       <p:sp>
         <p:nvSpPr>
-          <p:cNvPr id="16" name="Text 14"/>
+          <p:cNvPr id="12" name="Text 10"/>
           <p:cNvSpPr/>
           <p:nvPr/>
         </p:nvSpPr>
@@ -1805,7 +1722,7 @@
       </p:sp>
       <p:sp>
         <p:nvSpPr>
-          <p:cNvPr id="17" name="Text 15"/>
+          <p:cNvPr id="13" name="Text 11"/>
           <p:cNvSpPr/>
           <p:nvPr/>
         </p:nvSpPr>
@@ -1844,7 +1761,7 @@
       </p:sp>
       <p:sp>
         <p:nvSpPr>
-          <p:cNvPr id="18" name="Text 16"/>
+          <p:cNvPr id="14" name="Text 12"/>
           <p:cNvSpPr/>
           <p:nvPr/>
         </p:nvSpPr>
@@ -1883,7 +1800,7 @@
       </p:sp>
       <p:sp>
         <p:nvSpPr>
-          <p:cNvPr id="19" name="Text 17"/>
+          <p:cNvPr id="15" name="Text 13"/>
           <p:cNvSpPr/>
           <p:nvPr/>
         </p:nvSpPr>
@@ -1922,7 +1839,7 @@
       </p:sp>
       <p:sp>
         <p:nvSpPr>
-          <p:cNvPr id="20" name="Shape 18"/>
+          <p:cNvPr id="16" name="Shape 14"/>
           <p:cNvSpPr/>
           <p:nvPr/>
         </p:nvSpPr>
@@ -1949,7 +1866,7 @@
       </p:sp>
       <p:sp>
         <p:nvSpPr>
-          <p:cNvPr id="21" name="Shape 19"/>
+          <p:cNvPr id="17" name="Shape 15"/>
           <p:cNvSpPr/>
           <p:nvPr/>
         </p:nvSpPr>
@@ -1969,7 +1886,7 @@
       </p:sp>
       <p:sp>
         <p:nvSpPr>
-          <p:cNvPr id="22" name="Text 20"/>
+          <p:cNvPr id="18" name="Text 16"/>
           <p:cNvSpPr/>
           <p:nvPr/>
         </p:nvSpPr>
@@ -2008,7 +1925,7 @@
       </p:sp>
       <p:sp>
         <p:nvSpPr>
-          <p:cNvPr id="23" name="Text 21"/>
+          <p:cNvPr id="19" name="Text 17"/>
           <p:cNvSpPr/>
           <p:nvPr/>
         </p:nvSpPr>
@@ -2047,7 +1964,7 @@
       </p:sp>
       <p:sp>
         <p:nvSpPr>
-          <p:cNvPr id="24" name="Text 22"/>
+          <p:cNvPr id="20" name="Text 18"/>
           <p:cNvSpPr/>
           <p:nvPr/>
         </p:nvSpPr>
@@ -2086,7 +2003,7 @@
       </p:sp>
       <p:sp>
         <p:nvSpPr>
-          <p:cNvPr id="25" name="Text 23"/>
+          <p:cNvPr id="21" name="Text 19"/>
           <p:cNvSpPr/>
           <p:nvPr/>
         </p:nvSpPr>
@@ -2125,7 +2042,7 @@
       </p:sp>
       <p:sp>
         <p:nvSpPr>
-          <p:cNvPr id="26" name="Text 24"/>
+          <p:cNvPr id="22" name="Text 20"/>
           <p:cNvSpPr/>
           <p:nvPr/>
         </p:nvSpPr>
@@ -2164,7 +2081,7 @@
       </p:sp>
       <p:sp>
         <p:nvSpPr>
-          <p:cNvPr id="27" name="Text 25"/>
+          <p:cNvPr id="23" name="Text 21"/>
           <p:cNvSpPr/>
           <p:nvPr/>
         </p:nvSpPr>
@@ -2203,7 +2120,7 @@
       </p:sp>
       <p:sp>
         <p:nvSpPr>
-          <p:cNvPr id="28" name="Shape 26"/>
+          <p:cNvPr id="24" name="Shape 22"/>
           <p:cNvSpPr/>
           <p:nvPr/>
         </p:nvSpPr>
@@ -2230,7 +2147,7 @@
       </p:sp>
       <p:sp>
         <p:nvSpPr>
-          <p:cNvPr id="29" name="Shape 27"/>
+          <p:cNvPr id="25" name="Shape 23"/>
           <p:cNvSpPr/>
           <p:nvPr/>
         </p:nvSpPr>
@@ -2250,7 +2167,7 @@
       </p:sp>
       <p:sp>
         <p:nvSpPr>
-          <p:cNvPr id="30" name="Text 28"/>
+          <p:cNvPr id="26" name="Text 24"/>
           <p:cNvSpPr/>
           <p:nvPr/>
         </p:nvSpPr>
@@ -2289,7 +2206,7 @@
       </p:sp>
       <p:sp>
         <p:nvSpPr>
-          <p:cNvPr id="31" name="Text 29"/>
+          <p:cNvPr id="27" name="Text 25"/>
           <p:cNvSpPr/>
           <p:nvPr/>
         </p:nvSpPr>
@@ -2328,7 +2245,7 @@
       </p:sp>
       <p:sp>
         <p:nvSpPr>
-          <p:cNvPr id="32" name="Text 30"/>
+          <p:cNvPr id="28" name="Text 26"/>
           <p:cNvSpPr/>
           <p:nvPr/>
         </p:nvSpPr>
@@ -2367,7 +2284,7 @@
       </p:sp>
       <p:sp>
         <p:nvSpPr>
-          <p:cNvPr id="33" name="Text 31"/>
+          <p:cNvPr id="29" name="Text 27"/>
           <p:cNvSpPr/>
           <p:nvPr/>
         </p:nvSpPr>
@@ -2406,7 +2323,7 @@
       </p:sp>
       <p:sp>
         <p:nvSpPr>
-          <p:cNvPr id="34" name="Text 32"/>
+          <p:cNvPr id="30" name="Text 28"/>
           <p:cNvSpPr/>
           <p:nvPr/>
         </p:nvSpPr>
@@ -2445,7 +2362,7 @@
       </p:sp>
       <p:sp>
         <p:nvSpPr>
-          <p:cNvPr id="35" name="Text 33"/>
+          <p:cNvPr id="31" name="Text 29"/>
           <p:cNvSpPr/>
           <p:nvPr/>
         </p:nvSpPr>
@@ -2484,7 +2401,7 @@
       </p:sp>
       <p:sp>
         <p:nvSpPr>
-          <p:cNvPr id="36" name="Shape 34"/>
+          <p:cNvPr id="32" name="Shape 30"/>
           <p:cNvSpPr/>
           <p:nvPr/>
         </p:nvSpPr>
@@ -2504,7 +2421,7 @@
       </p:sp>
       <p:sp>
         <p:nvSpPr>
-          <p:cNvPr id="37" name="Text 35"/>
+          <p:cNvPr id="33" name="Text 31"/>
           <p:cNvSpPr/>
           <p:nvPr/>
         </p:nvSpPr>
@@ -2543,7 +2460,7 @@
       </p:sp>
       <p:sp>
         <p:nvSpPr>
-          <p:cNvPr id="38" name="Text 36"/>
+          <p:cNvPr id="34" name="Text 32"/>
           <p:cNvSpPr/>
           <p:nvPr/>
         </p:nvSpPr>

</xml_diff>